<commit_message>
Rebuild slide 2 natively; swap slide 6 device scope to 42+ inch TV screens
Slide 2: the cycle diagram was a flat JPEG, so its labels were unselectable
and stuck in the old blue/teal palette. Replaced with native CAMP shapes -
three stage cards (lime dot, forest heading, gray caption) joined by lime
chevrons, a return arrow closing the loop, a lime takeaway banner for
'Search & TV Working Together' and a bordered card for 'Cross-Channel
Retargeting'. All wording is carried over verbatim, including the six labels
lifted out of the image. Drops image1.jpg and repoints the slide at
slideLayout12, which has no stray bottom rule.

Slide 6: DEVICE SCOPE value changed from 'Cross Device' to
'42+ inch TV Screens'.

Co-Authored-By: Claude Opus 5 <noreply@anthropic.com>
Claude-Session: https://claude.ai/code/session_01MShSkqRtrzZURyqLpqY9E5
</commit_message>
<xml_diff>
--- a/tri-peaks-camp-redesign/Tri_Peaks_Pitch_Test_CAMP_Design.pptx
+++ b/tri-peaks-camp-redesign/Tri_Peaks_Pitch_Test_CAMP_Design.pptx
@@ -7650,14 +7650,14 @@
       </p:grpSpPr>
       <p:sp>
         <p:nvSpPr>
-          <p:cNvPr id="75" name="Google Shape;75;p16"/>
+          <p:cNvPr id="81" name="Google Shape;81;p16"/>
           <p:cNvSpPr/>
           <p:nvPr/>
         </p:nvSpPr>
         <p:spPr>
           <a:xfrm>
-            <a:off x="496119" y="393576"/>
-            <a:ext cx="8151600" cy="228300"/>
+            <a:off x="429768" y="274320"/>
+            <a:ext cx="8284464" cy="402336"/>
           </a:xfrm>
           <a:prstGeom prst="rect">
             <a:avLst/>
@@ -7668,69 +7668,158 @@
           </a:ln>
         </p:spPr>
         <p:txBody>
-          <a:bodyPr anchorCtr="0" anchor="t" bIns="0" lIns="0" spcFirstLastPara="1" rIns="0" wrap="square" tIns="0">
+          <a:bodyPr anchorCtr="0" anchor="ctr" bIns="0" lIns="0" spcFirstLastPara="1" rIns="0" wrap="square" tIns="0">
             <a:noAutofit/>
           </a:bodyPr>
           <a:lstStyle/>
           <a:p>
             <a:pPr indent="0" lvl="0" marL="0" marR="0" rtl="0" algn="l">
-              <a:lnSpc>
-                <a:spcPct val="104000"/>
-              </a:lnSpc>
-              <a:spcBef>
-                <a:spcPts val="0"/>
-              </a:spcBef>
-              <a:spcAft>
-                <a:spcPts val="0"/>
-              </a:spcAft>
-              <a:buClr>
-                <a:srgbClr val="666666"/>
-              </a:buClr>
-              <a:buSzPts val="1400"/>
-              <a:buFont typeface="Inter"/>
-              <a:buNone/>
-            </a:pPr>
-            <a:r>
-              <a:rPr b="1" i="0" lang="en" sz="1400" u="none" cap="none" strike="noStrike">
+              <a:spcBef>
+                <a:spcPts val="0"/>
+              </a:spcBef>
+              <a:spcAft>
+                <a:spcPts val="0"/>
+              </a:spcAft>
+              <a:buNone/>
+            </a:pPr>
+            <a:r>
+              <a:rPr b="1" i="0" lang="en" sz="2000">
                 <a:solidFill>
                   <a:srgbClr val="666666"/>
                 </a:solidFill>
-                <a:latin typeface="Inter"/>
-                <a:ea typeface="Inter"/>
-                <a:cs typeface="Inter"/>
-                <a:sym typeface="Inter"/>
+                <a:latin typeface="Arial"/>
+                <a:ea typeface="Arial"/>
+                <a:cs typeface="Arial"/>
+                <a:sym typeface="Arial"/>
               </a:rPr>
               <a:t>Building Brand Demand to Lower Your PPC Cost-Per-Lead.</a:t>
             </a:r>
-            <a:endParaRPr b="0" i="0" sz="1400" u="none" cap="none" strike="noStrike">
-              <a:solidFill>
-                <a:schemeClr val="dk1"/>
-              </a:solidFill>
-              <a:latin typeface="Arial"/>
-              <a:ea typeface="Arial"/>
-              <a:cs typeface="Arial"/>
-              <a:sym typeface="Arial"/>
-            </a:endParaRPr>
-          </a:p>
-        </p:txBody>
-      </p:sp>
-      <p:pic>
-        <p:nvPicPr>
-          <p:cNvPr descr="preencoded.png" id="76" name="Google Shape;76;p16"/>
-          <p:cNvPicPr preferRelativeResize="0"/>
+            <a:endParaRPr sz="2000"/>
+          </a:p>
+        </p:txBody>
+      </p:sp>
+      <p:sp>
+        <p:nvSpPr>
+          <p:cNvPr id="82" name="Google Shape;82;p16"/>
+          <p:cNvSpPr/>
           <p:nvPr/>
-        </p:nvPicPr>
-        <p:blipFill rotWithShape="1">
-          <a:blip r:embed="rId3">
-            <a:alphaModFix/>
-          </a:blip>
-          <a:srcRect b="0" l="0" r="0" t="0"/>
-          <a:stretch/>
-        </p:blipFill>
-        <p:spPr>
-          <a:xfrm>
-            <a:off x="496119" y="720849"/>
-            <a:ext cx="3986634" cy="3986731"/>
+        </p:nvSpPr>
+        <p:spPr>
+          <a:xfrm>
+            <a:off x="429768" y="932688"/>
+            <a:ext cx="2578608" cy="1389888"/>
+          </a:xfrm>
+          <a:prstGeom prst="roundRect">
+            <a:avLst>
+              <a:gd fmla="val 2799" name="adj"/>
+            </a:avLst>
+          </a:prstGeom>
+          <a:solidFill>
+            <a:srgbClr val="FFFFFF"/>
+          </a:solidFill>
+          <a:ln cap="flat" cmpd="sng" w="9525">
+            <a:solidFill>
+              <a:srgbClr val="A7C142"/>
+            </a:solidFill>
+            <a:prstDash val="solid"/>
+            <a:round/>
+            <a:headEnd len="sm" w="sm" type="none"/>
+            <a:tailEnd len="sm" w="sm" type="none"/>
+          </a:ln>
+        </p:spPr>
+        <p:txBody>
+          <a:bodyPr anchorCtr="0" anchor="t" bIns="0" lIns="0" spcFirstLastPara="1" rIns="0" wrap="square" tIns="0">
+            <a:noAutofit/>
+          </a:bodyPr>
+          <a:lstStyle/>
+          <a:p>
+            <a:pPr indent="0" lvl="0" marL="0" marR="0" rtl="0" algn="l">
+              <a:spcBef>
+                <a:spcPts val="0"/>
+              </a:spcBef>
+              <a:spcAft>
+                <a:spcPts val="0"/>
+              </a:spcAft>
+              <a:buNone/>
+            </a:pPr>
+            <a:r>
+              <a:rPr b="0" i="0" lang="en" sz="900">
+                <a:solidFill>
+                  <a:srgbClr val="666666"/>
+                </a:solidFill>
+                <a:latin typeface="Arial"/>
+                <a:ea typeface="Arial"/>
+                <a:cs typeface="Arial"/>
+                <a:sym typeface="Arial"/>
+              </a:rPr>
+              <a:t/>
+            </a:r>
+            <a:endParaRPr sz="900"/>
+          </a:p>
+        </p:txBody>
+      </p:sp>
+      <p:sp>
+        <p:nvSpPr>
+          <p:cNvPr id="83" name="Google Shape;83;p16"/>
+          <p:cNvSpPr/>
+          <p:nvPr/>
+        </p:nvSpPr>
+        <p:spPr>
+          <a:xfrm>
+            <a:off x="1636776" y="1170432"/>
+            <a:ext cx="164592" cy="164592"/>
+          </a:xfrm>
+          <a:prstGeom prst="ellipse">
+            <a:avLst/>
+          </a:prstGeom>
+          <a:solidFill>
+            <a:srgbClr val="A7C142"/>
+          </a:solidFill>
+          <a:ln>
+            <a:noFill/>
+          </a:ln>
+        </p:spPr>
+        <p:txBody>
+          <a:bodyPr anchorCtr="0" anchor="t" bIns="0" lIns="0" spcFirstLastPara="1" rIns="0" wrap="square" tIns="0">
+            <a:noAutofit/>
+          </a:bodyPr>
+          <a:lstStyle/>
+          <a:p>
+            <a:pPr indent="0" lvl="0" marL="0" marR="0" rtl="0" algn="l">
+              <a:spcBef>
+                <a:spcPts val="0"/>
+              </a:spcBef>
+              <a:spcAft>
+                <a:spcPts val="0"/>
+              </a:spcAft>
+              <a:buNone/>
+            </a:pPr>
+            <a:r>
+              <a:rPr b="0" i="0" lang="en" sz="900">
+                <a:solidFill>
+                  <a:srgbClr val="666666"/>
+                </a:solidFill>
+                <a:latin typeface="Arial"/>
+                <a:ea typeface="Arial"/>
+                <a:cs typeface="Arial"/>
+                <a:sym typeface="Arial"/>
+              </a:rPr>
+              <a:t/>
+            </a:r>
+            <a:endParaRPr sz="900"/>
+          </a:p>
+        </p:txBody>
+      </p:sp>
+      <p:sp>
+        <p:nvSpPr>
+          <p:cNvPr id="84" name="Google Shape;84;p16"/>
+          <p:cNvSpPr/>
+          <p:nvPr/>
+        </p:nvSpPr>
+        <p:spPr>
+          <a:xfrm>
+            <a:off x="576072" y="1389888"/>
+            <a:ext cx="2286000" cy="402336"/>
           </a:xfrm>
           <a:prstGeom prst="rect">
             <a:avLst/>
@@ -7740,17 +7829,50 @@
             <a:noFill/>
           </a:ln>
         </p:spPr>
-      </p:pic>
-      <p:sp>
-        <p:nvSpPr>
-          <p:cNvPr id="77" name="Google Shape;77;p16"/>
+        <p:txBody>
+          <a:bodyPr anchorCtr="0" anchor="b" bIns="0" lIns="0" spcFirstLastPara="1" rIns="0" wrap="square" tIns="0">
+            <a:noAutofit/>
+          </a:bodyPr>
+          <a:lstStyle/>
+          <a:p>
+            <a:pPr indent="0" lvl="0" marL="0" marR="0" rtl="0" algn="ctr">
+              <a:lnSpc>
+                <a:spcPct val="100000"/>
+              </a:lnSpc>
+              <a:spcBef>
+                <a:spcPts val="0"/>
+              </a:spcBef>
+              <a:spcAft>
+                <a:spcPts val="0"/>
+              </a:spcAft>
+              <a:buNone/>
+            </a:pPr>
+            <a:r>
+              <a:rPr b="1" i="0" lang="en" sz="1100">
+                <a:solidFill>
+                  <a:srgbClr val="003726"/>
+                </a:solidFill>
+                <a:latin typeface="Arial"/>
+                <a:ea typeface="Arial"/>
+                <a:cs typeface="Arial"/>
+                <a:sym typeface="Arial"/>
+              </a:rPr>
+              <a:t>CTV Awareness</a:t>
+            </a:r>
+            <a:endParaRPr sz="1100"/>
+          </a:p>
+        </p:txBody>
+      </p:sp>
+      <p:sp>
+        <p:nvSpPr>
+          <p:cNvPr id="85" name="Google Shape;85;p16"/>
           <p:cNvSpPr/>
           <p:nvPr/>
         </p:nvSpPr>
         <p:spPr>
           <a:xfrm>
-            <a:off x="4665918" y="2372023"/>
-            <a:ext cx="3986700" cy="114300"/>
+            <a:off x="576072" y="1819656"/>
+            <a:ext cx="2286000" cy="420624"/>
           </a:xfrm>
           <a:prstGeom prst="rect">
             <a:avLst/>
@@ -7766,9 +7888,9 @@
           </a:bodyPr>
           <a:lstStyle/>
           <a:p>
-            <a:pPr indent="0" lvl="0" marL="0" marR="0" rtl="0" algn="l">
+            <a:pPr indent="0" lvl="0" marL="0" marR="0" rtl="0" algn="ctr">
               <a:lnSpc>
-                <a:spcPct val="104000"/>
+                <a:spcPct val="100000"/>
               </a:lnSpc>
               <a:spcBef>
                 <a:spcPts val="0"/>
@@ -7776,47 +7898,198 @@
               <a:spcAft>
                 <a:spcPts val="0"/>
               </a:spcAft>
-              <a:buClr>
-                <a:srgbClr val="666666"/>
-              </a:buClr>
-              <a:buSzPts val="700"/>
-              <a:buFont typeface="Inter"/>
-              <a:buNone/>
-            </a:pPr>
-            <a:r>
-              <a:rPr b="1" i="0" lang="en" sz="700" u="none" cap="none" strike="noStrike">
+              <a:buNone/>
+            </a:pPr>
+            <a:r>
+              <a:rPr b="0" i="0" lang="en" sz="800">
                 <a:solidFill>
                   <a:srgbClr val="666666"/>
                 </a:solidFill>
-                <a:latin typeface="Inter"/>
-                <a:ea typeface="Inter"/>
-                <a:cs typeface="Inter"/>
-                <a:sym typeface="Inter"/>
+                <a:latin typeface="Arial"/>
+                <a:ea typeface="Arial"/>
+                <a:cs typeface="Arial"/>
+                <a:sym typeface="Arial"/>
               </a:rPr>
-              <a:t>Search &amp; TV Working Together</a:t>
-            </a:r>
-            <a:endParaRPr b="0" i="0" sz="700" u="none" cap="none" strike="noStrike">
-              <a:solidFill>
-                <a:schemeClr val="dk1"/>
-              </a:solidFill>
-              <a:latin typeface="Arial"/>
-              <a:ea typeface="Arial"/>
-              <a:cs typeface="Arial"/>
-              <a:sym typeface="Arial"/>
-            </a:endParaRPr>
-          </a:p>
-        </p:txBody>
-      </p:sp>
-      <p:sp>
-        <p:nvSpPr>
-          <p:cNvPr id="78" name="Google Shape;78;p16"/>
+              <a:t>(top-of-mind brand trust on living room screens)</a:t>
+            </a:r>
+            <a:endParaRPr sz="800"/>
+          </a:p>
+        </p:txBody>
+      </p:sp>
+      <p:sp>
+        <p:nvSpPr>
+          <p:cNvPr id="86" name="Google Shape;86;p16"/>
           <p:cNvSpPr/>
           <p:nvPr/>
         </p:nvSpPr>
         <p:spPr>
-          <a:xfrm>
-            <a:off x="4665918" y="2523902"/>
-            <a:ext cx="3986700" cy="177000"/>
+          <a:xfrm rot="5400000">
+            <a:off x="3063240" y="1536192"/>
+            <a:ext cx="164592" cy="182880"/>
+          </a:xfrm>
+          <a:prstGeom prst="triangle">
+            <a:avLst/>
+          </a:prstGeom>
+          <a:solidFill>
+            <a:srgbClr val="A7C142"/>
+          </a:solidFill>
+          <a:ln>
+            <a:noFill/>
+          </a:ln>
+        </p:spPr>
+        <p:txBody>
+          <a:bodyPr anchorCtr="0" anchor="t" bIns="0" lIns="0" spcFirstLastPara="1" rIns="0" wrap="square" tIns="0">
+            <a:noAutofit/>
+          </a:bodyPr>
+          <a:lstStyle/>
+          <a:p>
+            <a:pPr indent="0" lvl="0" marL="0" marR="0" rtl="0" algn="l">
+              <a:spcBef>
+                <a:spcPts val="0"/>
+              </a:spcBef>
+              <a:spcAft>
+                <a:spcPts val="0"/>
+              </a:spcAft>
+              <a:buNone/>
+            </a:pPr>
+            <a:r>
+              <a:rPr b="0" i="0" lang="en" sz="900">
+                <a:solidFill>
+                  <a:srgbClr val="666666"/>
+                </a:solidFill>
+                <a:latin typeface="Arial"/>
+                <a:ea typeface="Arial"/>
+                <a:cs typeface="Arial"/>
+                <a:sym typeface="Arial"/>
+              </a:rPr>
+              <a:t/>
+            </a:r>
+            <a:endParaRPr sz="900"/>
+          </a:p>
+        </p:txBody>
+      </p:sp>
+      <p:sp>
+        <p:nvSpPr>
+          <p:cNvPr id="87" name="Google Shape;87;p16"/>
+          <p:cNvSpPr/>
+          <p:nvPr/>
+        </p:nvSpPr>
+        <p:spPr>
+          <a:xfrm>
+            <a:off x="3282696" y="932688"/>
+            <a:ext cx="2578608" cy="1389888"/>
+          </a:xfrm>
+          <a:prstGeom prst="roundRect">
+            <a:avLst>
+              <a:gd fmla="val 2799" name="adj"/>
+            </a:avLst>
+          </a:prstGeom>
+          <a:solidFill>
+            <a:srgbClr val="FFFFFF"/>
+          </a:solidFill>
+          <a:ln cap="flat" cmpd="sng" w="9525">
+            <a:solidFill>
+              <a:srgbClr val="A7C142"/>
+            </a:solidFill>
+            <a:prstDash val="solid"/>
+            <a:round/>
+            <a:headEnd len="sm" w="sm" type="none"/>
+            <a:tailEnd len="sm" w="sm" type="none"/>
+          </a:ln>
+        </p:spPr>
+        <p:txBody>
+          <a:bodyPr anchorCtr="0" anchor="t" bIns="0" lIns="0" spcFirstLastPara="1" rIns="0" wrap="square" tIns="0">
+            <a:noAutofit/>
+          </a:bodyPr>
+          <a:lstStyle/>
+          <a:p>
+            <a:pPr indent="0" lvl="0" marL="0" marR="0" rtl="0" algn="l">
+              <a:spcBef>
+                <a:spcPts val="0"/>
+              </a:spcBef>
+              <a:spcAft>
+                <a:spcPts val="0"/>
+              </a:spcAft>
+              <a:buNone/>
+            </a:pPr>
+            <a:r>
+              <a:rPr b="0" i="0" lang="en" sz="900">
+                <a:solidFill>
+                  <a:srgbClr val="666666"/>
+                </a:solidFill>
+                <a:latin typeface="Arial"/>
+                <a:ea typeface="Arial"/>
+                <a:cs typeface="Arial"/>
+                <a:sym typeface="Arial"/>
+              </a:rPr>
+              <a:t/>
+            </a:r>
+            <a:endParaRPr sz="900"/>
+          </a:p>
+        </p:txBody>
+      </p:sp>
+      <p:sp>
+        <p:nvSpPr>
+          <p:cNvPr id="88" name="Google Shape;88;p16"/>
+          <p:cNvSpPr/>
+          <p:nvPr/>
+        </p:nvSpPr>
+        <p:spPr>
+          <a:xfrm>
+            <a:off x="4489704" y="1170432"/>
+            <a:ext cx="164592" cy="164592"/>
+          </a:xfrm>
+          <a:prstGeom prst="ellipse">
+            <a:avLst/>
+          </a:prstGeom>
+          <a:solidFill>
+            <a:srgbClr val="A7C142"/>
+          </a:solidFill>
+          <a:ln>
+            <a:noFill/>
+          </a:ln>
+        </p:spPr>
+        <p:txBody>
+          <a:bodyPr anchorCtr="0" anchor="t" bIns="0" lIns="0" spcFirstLastPara="1" rIns="0" wrap="square" tIns="0">
+            <a:noAutofit/>
+          </a:bodyPr>
+          <a:lstStyle/>
+          <a:p>
+            <a:pPr indent="0" lvl="0" marL="0" marR="0" rtl="0" algn="l">
+              <a:spcBef>
+                <a:spcPts val="0"/>
+              </a:spcBef>
+              <a:spcAft>
+                <a:spcPts val="0"/>
+              </a:spcAft>
+              <a:buNone/>
+            </a:pPr>
+            <a:r>
+              <a:rPr b="0" i="0" lang="en" sz="900">
+                <a:solidFill>
+                  <a:srgbClr val="666666"/>
+                </a:solidFill>
+                <a:latin typeface="Arial"/>
+                <a:ea typeface="Arial"/>
+                <a:cs typeface="Arial"/>
+                <a:sym typeface="Arial"/>
+              </a:rPr>
+              <a:t/>
+            </a:r>
+            <a:endParaRPr sz="900"/>
+          </a:p>
+        </p:txBody>
+      </p:sp>
+      <p:sp>
+        <p:nvSpPr>
+          <p:cNvPr id="89" name="Google Shape;89;p16"/>
+          <p:cNvSpPr/>
+          <p:nvPr/>
+        </p:nvSpPr>
+        <p:spPr>
+          <a:xfrm>
+            <a:off x="3429000" y="1389888"/>
+            <a:ext cx="2286000" cy="402336"/>
           </a:xfrm>
           <a:prstGeom prst="rect">
             <a:avLst/>
@@ -7827,14 +8100,67 @@
           </a:ln>
         </p:spPr>
         <p:txBody>
+          <a:bodyPr anchorCtr="0" anchor="b" bIns="0" lIns="0" spcFirstLastPara="1" rIns="0" wrap="square" tIns="0">
+            <a:noAutofit/>
+          </a:bodyPr>
+          <a:lstStyle/>
+          <a:p>
+            <a:pPr indent="0" lvl="0" marL="0" marR="0" rtl="0" algn="ctr">
+              <a:lnSpc>
+                <a:spcPct val="100000"/>
+              </a:lnSpc>
+              <a:spcBef>
+                <a:spcPts val="0"/>
+              </a:spcBef>
+              <a:spcAft>
+                <a:spcPts val="0"/>
+              </a:spcAft>
+              <a:buNone/>
+            </a:pPr>
+            <a:r>
+              <a:rPr b="1" i="0" lang="en" sz="1100">
+                <a:solidFill>
+                  <a:srgbClr val="003726"/>
+                </a:solidFill>
+                <a:latin typeface="Arial"/>
+                <a:ea typeface="Arial"/>
+                <a:cs typeface="Arial"/>
+                <a:sym typeface="Arial"/>
+              </a:rPr>
+              <a:t>Branded Searches</a:t>
+            </a:r>
+            <a:endParaRPr sz="1100"/>
+          </a:p>
+        </p:txBody>
+      </p:sp>
+      <p:sp>
+        <p:nvSpPr>
+          <p:cNvPr id="90" name="Google Shape;90;p16"/>
+          <p:cNvSpPr/>
+          <p:nvPr/>
+        </p:nvSpPr>
+        <p:spPr>
+          <a:xfrm>
+            <a:off x="3429000" y="1819656"/>
+            <a:ext cx="2286000" cy="420624"/>
+          </a:xfrm>
+          <a:prstGeom prst="rect">
+            <a:avLst/>
+          </a:prstGeom>
+          <a:noFill/>
+          <a:ln>
+            <a:noFill/>
+          </a:ln>
+        </p:spPr>
+        <p:txBody>
           <a:bodyPr anchorCtr="0" anchor="t" bIns="0" lIns="0" spcFirstLastPara="1" rIns="0" wrap="square" tIns="0">
             <a:noAutofit/>
           </a:bodyPr>
           <a:lstStyle/>
           <a:p>
-            <a:pPr indent="0" lvl="0" marL="0" marR="0" rtl="0" algn="l">
+            <a:pPr indent="0" lvl="0" marL="0" marR="0" rtl="0" algn="ctr">
               <a:lnSpc>
-                <a:spcPct val="101000"/>
+                <a:spcPct val="100000"/>
               </a:lnSpc>
               <a:spcBef>
                 <a:spcPts val="0"/>
@@ -7842,47 +8168,198 @@
               <a:spcAft>
                 <a:spcPts val="0"/>
               </a:spcAft>
-              <a:buClr>
-                <a:srgbClr val="666666"/>
-              </a:buClr>
-              <a:buSzPts val="600"/>
-              <a:buFont typeface="Inter"/>
-              <a:buNone/>
-            </a:pPr>
-            <a:r>
-              <a:rPr b="0" i="0" lang="en" sz="600" u="none" cap="none" strike="noStrike">
+              <a:buNone/>
+            </a:pPr>
+            <a:r>
+              <a:rPr b="0" i="0" lang="en" sz="800">
                 <a:solidFill>
                   <a:srgbClr val="666666"/>
                 </a:solidFill>
-                <a:latin typeface="Inter"/>
-                <a:ea typeface="Inter"/>
-                <a:cs typeface="Inter"/>
-                <a:sym typeface="Inter"/>
+                <a:latin typeface="Arial"/>
+                <a:ea typeface="Arial"/>
+                <a:cs typeface="Arial"/>
+                <a:sym typeface="Arial"/>
               </a:rPr>
-              <a:t>CTV creates top-of-mind trust. Search PPC captures the appointment when the repair is needed. Together, they compound your results.</a:t>
-            </a:r>
-            <a:endParaRPr b="0" i="0" sz="600" u="none" cap="none" strike="noStrike">
-              <a:solidFill>
-                <a:schemeClr val="dk1"/>
-              </a:solidFill>
-              <a:latin typeface="Arial"/>
-              <a:ea typeface="Arial"/>
-              <a:cs typeface="Arial"/>
-              <a:sym typeface="Arial"/>
-            </a:endParaRPr>
-          </a:p>
-        </p:txBody>
-      </p:sp>
-      <p:sp>
-        <p:nvSpPr>
-          <p:cNvPr id="79" name="Google Shape;79;p16"/>
+              <a:t>(homeowners search your name directly)</a:t>
+            </a:r>
+            <a:endParaRPr sz="800"/>
+          </a:p>
+        </p:txBody>
+      </p:sp>
+      <p:sp>
+        <p:nvSpPr>
+          <p:cNvPr id="91" name="Google Shape;91;p16"/>
           <p:cNvSpPr/>
           <p:nvPr/>
         </p:nvSpPr>
         <p:spPr>
-          <a:xfrm>
-            <a:off x="4665918" y="2738661"/>
-            <a:ext cx="3986700" cy="114300"/>
+          <a:xfrm rot="5400000">
+            <a:off x="5916168" y="1536192"/>
+            <a:ext cx="164592" cy="182880"/>
+          </a:xfrm>
+          <a:prstGeom prst="triangle">
+            <a:avLst/>
+          </a:prstGeom>
+          <a:solidFill>
+            <a:srgbClr val="A7C142"/>
+          </a:solidFill>
+          <a:ln>
+            <a:noFill/>
+          </a:ln>
+        </p:spPr>
+        <p:txBody>
+          <a:bodyPr anchorCtr="0" anchor="t" bIns="0" lIns="0" spcFirstLastPara="1" rIns="0" wrap="square" tIns="0">
+            <a:noAutofit/>
+          </a:bodyPr>
+          <a:lstStyle/>
+          <a:p>
+            <a:pPr indent="0" lvl="0" marL="0" marR="0" rtl="0" algn="l">
+              <a:spcBef>
+                <a:spcPts val="0"/>
+              </a:spcBef>
+              <a:spcAft>
+                <a:spcPts val="0"/>
+              </a:spcAft>
+              <a:buNone/>
+            </a:pPr>
+            <a:r>
+              <a:rPr b="0" i="0" lang="en" sz="900">
+                <a:solidFill>
+                  <a:srgbClr val="666666"/>
+                </a:solidFill>
+                <a:latin typeface="Arial"/>
+                <a:ea typeface="Arial"/>
+                <a:cs typeface="Arial"/>
+                <a:sym typeface="Arial"/>
+              </a:rPr>
+              <a:t/>
+            </a:r>
+            <a:endParaRPr sz="900"/>
+          </a:p>
+        </p:txBody>
+      </p:sp>
+      <p:sp>
+        <p:nvSpPr>
+          <p:cNvPr id="92" name="Google Shape;92;p16"/>
+          <p:cNvSpPr/>
+          <p:nvPr/>
+        </p:nvSpPr>
+        <p:spPr>
+          <a:xfrm>
+            <a:off x="6135624" y="932688"/>
+            <a:ext cx="2578608" cy="1389888"/>
+          </a:xfrm>
+          <a:prstGeom prst="roundRect">
+            <a:avLst>
+              <a:gd fmla="val 2799" name="adj"/>
+            </a:avLst>
+          </a:prstGeom>
+          <a:solidFill>
+            <a:srgbClr val="FFFFFF"/>
+          </a:solidFill>
+          <a:ln cap="flat" cmpd="sng" w="9525">
+            <a:solidFill>
+              <a:srgbClr val="A7C142"/>
+            </a:solidFill>
+            <a:prstDash val="solid"/>
+            <a:round/>
+            <a:headEnd len="sm" w="sm" type="none"/>
+            <a:tailEnd len="sm" w="sm" type="none"/>
+          </a:ln>
+        </p:spPr>
+        <p:txBody>
+          <a:bodyPr anchorCtr="0" anchor="t" bIns="0" lIns="0" spcFirstLastPara="1" rIns="0" wrap="square" tIns="0">
+            <a:noAutofit/>
+          </a:bodyPr>
+          <a:lstStyle/>
+          <a:p>
+            <a:pPr indent="0" lvl="0" marL="0" marR="0" rtl="0" algn="l">
+              <a:spcBef>
+                <a:spcPts val="0"/>
+              </a:spcBef>
+              <a:spcAft>
+                <a:spcPts val="0"/>
+              </a:spcAft>
+              <a:buNone/>
+            </a:pPr>
+            <a:r>
+              <a:rPr b="0" i="0" lang="en" sz="900">
+                <a:solidFill>
+                  <a:srgbClr val="666666"/>
+                </a:solidFill>
+                <a:latin typeface="Arial"/>
+                <a:ea typeface="Arial"/>
+                <a:cs typeface="Arial"/>
+                <a:sym typeface="Arial"/>
+              </a:rPr>
+              <a:t/>
+            </a:r>
+            <a:endParaRPr sz="900"/>
+          </a:p>
+        </p:txBody>
+      </p:sp>
+      <p:sp>
+        <p:nvSpPr>
+          <p:cNvPr id="93" name="Google Shape;93;p16"/>
+          <p:cNvSpPr/>
+          <p:nvPr/>
+        </p:nvSpPr>
+        <p:spPr>
+          <a:xfrm>
+            <a:off x="7342632" y="1170432"/>
+            <a:ext cx="164592" cy="164592"/>
+          </a:xfrm>
+          <a:prstGeom prst="ellipse">
+            <a:avLst/>
+          </a:prstGeom>
+          <a:solidFill>
+            <a:srgbClr val="A7C142"/>
+          </a:solidFill>
+          <a:ln>
+            <a:noFill/>
+          </a:ln>
+        </p:spPr>
+        <p:txBody>
+          <a:bodyPr anchorCtr="0" anchor="t" bIns="0" lIns="0" spcFirstLastPara="1" rIns="0" wrap="square" tIns="0">
+            <a:noAutofit/>
+          </a:bodyPr>
+          <a:lstStyle/>
+          <a:p>
+            <a:pPr indent="0" lvl="0" marL="0" marR="0" rtl="0" algn="l">
+              <a:spcBef>
+                <a:spcPts val="0"/>
+              </a:spcBef>
+              <a:spcAft>
+                <a:spcPts val="0"/>
+              </a:spcAft>
+              <a:buNone/>
+            </a:pPr>
+            <a:r>
+              <a:rPr b="0" i="0" lang="en" sz="900">
+                <a:solidFill>
+                  <a:srgbClr val="666666"/>
+                </a:solidFill>
+                <a:latin typeface="Arial"/>
+                <a:ea typeface="Arial"/>
+                <a:cs typeface="Arial"/>
+                <a:sym typeface="Arial"/>
+              </a:rPr>
+              <a:t/>
+            </a:r>
+            <a:endParaRPr sz="900"/>
+          </a:p>
+        </p:txBody>
+      </p:sp>
+      <p:sp>
+        <p:nvSpPr>
+          <p:cNvPr id="94" name="Google Shape;94;p16"/>
+          <p:cNvSpPr/>
+          <p:nvPr/>
+        </p:nvSpPr>
+        <p:spPr>
+          <a:xfrm>
+            <a:off x="6281928" y="1389888"/>
+            <a:ext cx="2286000" cy="402336"/>
           </a:xfrm>
           <a:prstGeom prst="rect">
             <a:avLst/>
@@ -7893,14 +8370,67 @@
           </a:ln>
         </p:spPr>
         <p:txBody>
+          <a:bodyPr anchorCtr="0" anchor="b" bIns="0" lIns="0" spcFirstLastPara="1" rIns="0" wrap="square" tIns="0">
+            <a:noAutofit/>
+          </a:bodyPr>
+          <a:lstStyle/>
+          <a:p>
+            <a:pPr indent="0" lvl="0" marL="0" marR="0" rtl="0" algn="ctr">
+              <a:lnSpc>
+                <a:spcPct val="100000"/>
+              </a:lnSpc>
+              <a:spcBef>
+                <a:spcPts val="0"/>
+              </a:spcBef>
+              <a:spcAft>
+                <a:spcPts val="0"/>
+              </a:spcAft>
+              <a:buNone/>
+            </a:pPr>
+            <a:r>
+              <a:rPr b="1" i="0" lang="en" sz="1100">
+                <a:solidFill>
+                  <a:srgbClr val="003726"/>
+                </a:solidFill>
+                <a:latin typeface="Arial"/>
+                <a:ea typeface="Arial"/>
+                <a:cs typeface="Arial"/>
+                <a:sym typeface="Arial"/>
+              </a:rPr>
+              <a:t>Lower CPL and Higher PPC Conversion Rates</a:t>
+            </a:r>
+            <a:endParaRPr sz="1100"/>
+          </a:p>
+        </p:txBody>
+      </p:sp>
+      <p:sp>
+        <p:nvSpPr>
+          <p:cNvPr id="95" name="Google Shape;95;p16"/>
+          <p:cNvSpPr/>
+          <p:nvPr/>
+        </p:nvSpPr>
+        <p:spPr>
+          <a:xfrm>
+            <a:off x="6281928" y="1819656"/>
+            <a:ext cx="2286000" cy="420624"/>
+          </a:xfrm>
+          <a:prstGeom prst="rect">
+            <a:avLst/>
+          </a:prstGeom>
+          <a:noFill/>
+          <a:ln>
+            <a:noFill/>
+          </a:ln>
+        </p:spPr>
+        <p:txBody>
           <a:bodyPr anchorCtr="0" anchor="t" bIns="0" lIns="0" spcFirstLastPara="1" rIns="0" wrap="square" tIns="0">
             <a:noAutofit/>
           </a:bodyPr>
           <a:lstStyle/>
           <a:p>
-            <a:pPr indent="0" lvl="0" marL="0" marR="0" rtl="0" algn="l">
+            <a:pPr indent="0" lvl="0" marL="0" marR="0" rtl="0" algn="ctr">
               <a:lnSpc>
-                <a:spcPct val="104000"/>
+                <a:spcPct val="100000"/>
               </a:lnSpc>
               <a:spcBef>
                 <a:spcPts val="0"/>
@@ -7908,47 +8438,140 @@
               <a:spcAft>
                 <a:spcPts val="0"/>
               </a:spcAft>
-              <a:buClr>
-                <a:srgbClr val="666666"/>
-              </a:buClr>
-              <a:buSzPts val="700"/>
-              <a:buFont typeface="Inter"/>
-              <a:buNone/>
-            </a:pPr>
-            <a:r>
-              <a:rPr b="1" i="0" lang="en" sz="700" u="none" cap="none" strike="noStrike">
+              <a:buNone/>
+            </a:pPr>
+            <a:r>
+              <a:rPr b="0" i="0" lang="en" sz="800">
                 <a:solidFill>
                   <a:srgbClr val="666666"/>
                 </a:solidFill>
-                <a:latin typeface="Inter"/>
-                <a:ea typeface="Inter"/>
-                <a:cs typeface="Inter"/>
-                <a:sym typeface="Inter"/>
+                <a:latin typeface="Arial"/>
+                <a:ea typeface="Arial"/>
+                <a:cs typeface="Arial"/>
+                <a:sym typeface="Arial"/>
               </a:rPr>
-              <a:t>Cross-Channel Retargeting</a:t>
-            </a:r>
-            <a:endParaRPr b="0" i="0" sz="700" u="none" cap="none" strike="noStrike">
-              <a:solidFill>
-                <a:schemeClr val="dk1"/>
-              </a:solidFill>
-              <a:latin typeface="Arial"/>
-              <a:ea typeface="Arial"/>
-              <a:cs typeface="Arial"/>
-              <a:sym typeface="Arial"/>
-            </a:endParaRPr>
-          </a:p>
-        </p:txBody>
-      </p:sp>
-      <p:sp>
-        <p:nvSpPr>
-          <p:cNvPr id="80" name="Google Shape;80;p16"/>
+              <a:t>(higher CTR, lower acquisition cost)</a:t>
+            </a:r>
+            <a:endParaRPr sz="800"/>
+          </a:p>
+        </p:txBody>
+      </p:sp>
+      <p:sp>
+        <p:nvSpPr>
+          <p:cNvPr id="96" name="Google Shape;96;p16"/>
           <p:cNvSpPr/>
           <p:nvPr/>
         </p:nvSpPr>
         <p:spPr>
           <a:xfrm>
-            <a:off x="4665918" y="2890540"/>
-            <a:ext cx="3986700" cy="190200"/>
+            <a:off x="1719072" y="2487168"/>
+            <a:ext cx="5705856" cy="118872"/>
+          </a:xfrm>
+          <a:prstGeom prst="leftArrow">
+            <a:avLst/>
+          </a:prstGeom>
+          <a:solidFill>
+            <a:srgbClr val="A7C142"/>
+          </a:solidFill>
+          <a:ln>
+            <a:noFill/>
+          </a:ln>
+        </p:spPr>
+        <p:txBody>
+          <a:bodyPr anchorCtr="0" anchor="t" bIns="0" lIns="0" spcFirstLastPara="1" rIns="0" wrap="square" tIns="0">
+            <a:noAutofit/>
+          </a:bodyPr>
+          <a:lstStyle/>
+          <a:p>
+            <a:pPr indent="0" lvl="0" marL="0" marR="0" rtl="0" algn="l">
+              <a:spcBef>
+                <a:spcPts val="0"/>
+              </a:spcBef>
+              <a:spcAft>
+                <a:spcPts val="0"/>
+              </a:spcAft>
+              <a:buNone/>
+            </a:pPr>
+            <a:r>
+              <a:rPr b="0" i="0" lang="en" sz="900">
+                <a:solidFill>
+                  <a:srgbClr val="666666"/>
+                </a:solidFill>
+                <a:latin typeface="Arial"/>
+                <a:ea typeface="Arial"/>
+                <a:cs typeface="Arial"/>
+                <a:sym typeface="Arial"/>
+              </a:rPr>
+              <a:t/>
+            </a:r>
+            <a:endParaRPr sz="900"/>
+          </a:p>
+        </p:txBody>
+      </p:sp>
+      <p:sp>
+        <p:nvSpPr>
+          <p:cNvPr id="97" name="Google Shape;97;p16"/>
+          <p:cNvSpPr/>
+          <p:nvPr/>
+        </p:nvSpPr>
+        <p:spPr>
+          <a:xfrm>
+            <a:off x="429768" y="2816352"/>
+            <a:ext cx="8284464" cy="640080"/>
+          </a:xfrm>
+          <a:prstGeom prst="roundRect">
+            <a:avLst>
+              <a:gd fmla="val 2799" name="adj"/>
+            </a:avLst>
+          </a:prstGeom>
+          <a:solidFill>
+            <a:srgbClr val="A7C142"/>
+          </a:solidFill>
+          <a:ln>
+            <a:noFill/>
+          </a:ln>
+        </p:spPr>
+        <p:txBody>
+          <a:bodyPr anchorCtr="0" anchor="t" bIns="0" lIns="0" spcFirstLastPara="1" rIns="0" wrap="square" tIns="0">
+            <a:noAutofit/>
+          </a:bodyPr>
+          <a:lstStyle/>
+          <a:p>
+            <a:pPr indent="0" lvl="0" marL="0" marR="0" rtl="0" algn="l">
+              <a:spcBef>
+                <a:spcPts val="0"/>
+              </a:spcBef>
+              <a:spcAft>
+                <a:spcPts val="0"/>
+              </a:spcAft>
+              <a:buNone/>
+            </a:pPr>
+            <a:r>
+              <a:rPr b="0" i="0" lang="en" sz="900">
+                <a:solidFill>
+                  <a:srgbClr val="666666"/>
+                </a:solidFill>
+                <a:latin typeface="Arial"/>
+                <a:ea typeface="Arial"/>
+                <a:cs typeface="Arial"/>
+                <a:sym typeface="Arial"/>
+              </a:rPr>
+              <a:t/>
+            </a:r>
+            <a:endParaRPr sz="900"/>
+          </a:p>
+        </p:txBody>
+      </p:sp>
+      <p:sp>
+        <p:nvSpPr>
+          <p:cNvPr id="98" name="Google Shape;98;p16"/>
+          <p:cNvSpPr/>
+          <p:nvPr/>
+        </p:nvSpPr>
+        <p:spPr>
+          <a:xfrm>
+            <a:off x="658368" y="2926080"/>
+            <a:ext cx="7827264" cy="164592"/>
           </a:xfrm>
           <a:prstGeom prst="rect">
             <a:avLst/>
@@ -7959,67 +8582,263 @@
           </a:ln>
         </p:spPr>
         <p:txBody>
-          <a:bodyPr anchorCtr="0" anchor="t" bIns="0" lIns="0" spcFirstLastPara="1" rIns="0" wrap="square" tIns="29225">
-            <a:noAutofit/>
-          </a:bodyPr>
-          <a:lstStyle/>
-          <a:p>
-            <a:pPr indent="-114300" lvl="0" marL="114300" marR="0" rtl="0" algn="l">
-              <a:lnSpc>
-                <a:spcPct val="101000"/>
-              </a:lnSpc>
-              <a:spcBef>
-                <a:spcPts val="0"/>
-              </a:spcBef>
-              <a:spcAft>
-                <a:spcPts val="0"/>
-              </a:spcAft>
-              <a:buClr>
-                <a:srgbClr val="666666"/>
-              </a:buClr>
-              <a:buSzPts val="600"/>
-              <a:buFont typeface="Inter"/>
-              <a:buChar char="•"/>
-            </a:pPr>
-            <a:r>
-              <a:rPr b="1" i="0" lang="en" sz="600" u="none" cap="none" strike="noStrike">
+          <a:bodyPr anchorCtr="0" anchor="ctr" bIns="0" lIns="0" spcFirstLastPara="1" rIns="0" wrap="square" tIns="0">
+            <a:noAutofit/>
+          </a:bodyPr>
+          <a:lstStyle/>
+          <a:p>
+            <a:pPr indent="0" lvl="0" marL="0" marR="0" rtl="0" algn="l">
+              <a:spcBef>
+                <a:spcPts val="0"/>
+              </a:spcBef>
+              <a:spcAft>
+                <a:spcPts val="0"/>
+              </a:spcAft>
+              <a:buNone/>
+            </a:pPr>
+            <a:r>
+              <a:rPr b="1" i="0" lang="en" sz="900">
+                <a:solidFill>
+                  <a:srgbClr val="003726"/>
+                </a:solidFill>
+                <a:latin typeface="Arial"/>
+                <a:ea typeface="Arial"/>
+                <a:cs typeface="Arial"/>
+                <a:sym typeface="Arial"/>
+              </a:rPr>
+              <a:t>Search &amp; TV Working Together</a:t>
+            </a:r>
+            <a:endParaRPr sz="900"/>
+          </a:p>
+        </p:txBody>
+      </p:sp>
+      <p:sp>
+        <p:nvSpPr>
+          <p:cNvPr id="99" name="Google Shape;99;p16"/>
+          <p:cNvSpPr/>
+          <p:nvPr/>
+        </p:nvSpPr>
+        <p:spPr>
+          <a:xfrm>
+            <a:off x="658368" y="3118104"/>
+            <a:ext cx="7827264" cy="201168"/>
+          </a:xfrm>
+          <a:prstGeom prst="rect">
+            <a:avLst/>
+          </a:prstGeom>
+          <a:noFill/>
+          <a:ln>
+            <a:noFill/>
+          </a:ln>
+        </p:spPr>
+        <p:txBody>
+          <a:bodyPr anchorCtr="0" anchor="ctr" bIns="0" lIns="0" spcFirstLastPara="1" rIns="0" wrap="square" tIns="0">
+            <a:noAutofit/>
+          </a:bodyPr>
+          <a:lstStyle/>
+          <a:p>
+            <a:pPr indent="0" lvl="0" marL="0" marR="0" rtl="0" algn="l">
+              <a:spcBef>
+                <a:spcPts val="0"/>
+              </a:spcBef>
+              <a:spcAft>
+                <a:spcPts val="0"/>
+              </a:spcAft>
+              <a:buNone/>
+            </a:pPr>
+            <a:r>
+              <a:rPr b="0" i="0" lang="en" sz="800">
+                <a:solidFill>
+                  <a:srgbClr val="003726"/>
+                </a:solidFill>
+                <a:latin typeface="Arial"/>
+                <a:ea typeface="Arial"/>
+                <a:cs typeface="Arial"/>
+                <a:sym typeface="Arial"/>
+              </a:rPr>
+              <a:t>CTV creates top-of-mind trust. Search PPC captures the appointment when the repair is needed. Together, they compound your results.</a:t>
+            </a:r>
+            <a:endParaRPr sz="800"/>
+          </a:p>
+        </p:txBody>
+      </p:sp>
+      <p:sp>
+        <p:nvSpPr>
+          <p:cNvPr id="100" name="Google Shape;100;p16"/>
+          <p:cNvSpPr/>
+          <p:nvPr/>
+        </p:nvSpPr>
+        <p:spPr>
+          <a:xfrm>
+            <a:off x="429768" y="3621024"/>
+            <a:ext cx="8284464" cy="914400"/>
+          </a:xfrm>
+          <a:prstGeom prst="roundRect">
+            <a:avLst>
+              <a:gd fmla="val 2799" name="adj"/>
+            </a:avLst>
+          </a:prstGeom>
+          <a:solidFill>
+            <a:srgbClr val="FFFFFF"/>
+          </a:solidFill>
+          <a:ln cap="flat" cmpd="sng" w="9525">
+            <a:solidFill>
+              <a:srgbClr val="A7C142"/>
+            </a:solidFill>
+            <a:prstDash val="solid"/>
+            <a:round/>
+            <a:headEnd len="sm" w="sm" type="none"/>
+            <a:tailEnd len="sm" w="sm" type="none"/>
+          </a:ln>
+        </p:spPr>
+        <p:txBody>
+          <a:bodyPr anchorCtr="0" anchor="t" bIns="0" lIns="0" spcFirstLastPara="1" rIns="0" wrap="square" tIns="0">
+            <a:noAutofit/>
+          </a:bodyPr>
+          <a:lstStyle/>
+          <a:p>
+            <a:pPr indent="0" lvl="0" marL="0" marR="0" rtl="0" algn="l">
+              <a:spcBef>
+                <a:spcPts val="0"/>
+              </a:spcBef>
+              <a:spcAft>
+                <a:spcPts val="0"/>
+              </a:spcAft>
+              <a:buNone/>
+            </a:pPr>
+            <a:r>
+              <a:rPr b="0" i="0" lang="en" sz="900">
                 <a:solidFill>
                   <a:srgbClr val="666666"/>
                 </a:solidFill>
-                <a:latin typeface="Inter"/>
-                <a:ea typeface="Inter"/>
-                <a:cs typeface="Inter"/>
-                <a:sym typeface="Inter"/>
+                <a:latin typeface="Arial"/>
+                <a:ea typeface="Arial"/>
+                <a:cs typeface="Arial"/>
+                <a:sym typeface="Arial"/>
+              </a:rPr>
+              <a:t/>
+            </a:r>
+            <a:endParaRPr sz="900"/>
+          </a:p>
+        </p:txBody>
+      </p:sp>
+      <p:sp>
+        <p:nvSpPr>
+          <p:cNvPr id="101" name="Google Shape;101;p16"/>
+          <p:cNvSpPr/>
+          <p:nvPr/>
+        </p:nvSpPr>
+        <p:spPr>
+          <a:xfrm>
+            <a:off x="658368" y="3749040"/>
+            <a:ext cx="7827264" cy="164592"/>
+          </a:xfrm>
+          <a:prstGeom prst="rect">
+            <a:avLst/>
+          </a:prstGeom>
+          <a:noFill/>
+          <a:ln>
+            <a:noFill/>
+          </a:ln>
+        </p:spPr>
+        <p:txBody>
+          <a:bodyPr anchorCtr="0" anchor="ctr" bIns="0" lIns="0" spcFirstLastPara="1" rIns="0" wrap="square" tIns="0">
+            <a:noAutofit/>
+          </a:bodyPr>
+          <a:lstStyle/>
+          <a:p>
+            <a:pPr indent="0" lvl="0" marL="0" marR="0" rtl="0" algn="l">
+              <a:spcBef>
+                <a:spcPts val="0"/>
+              </a:spcBef>
+              <a:spcAft>
+                <a:spcPts val="0"/>
+              </a:spcAft>
+              <a:buNone/>
+            </a:pPr>
+            <a:r>
+              <a:rPr b="1" i="0" lang="en" sz="900">
+                <a:solidFill>
+                  <a:srgbClr val="003726"/>
+                </a:solidFill>
+                <a:latin typeface="Arial"/>
+                <a:ea typeface="Arial"/>
+                <a:cs typeface="Arial"/>
+                <a:sym typeface="Arial"/>
+              </a:rPr>
+              <a:t>Cross-Channel Retargeting</a:t>
+            </a:r>
+            <a:endParaRPr sz="900"/>
+          </a:p>
+        </p:txBody>
+      </p:sp>
+      <p:sp>
+        <p:nvSpPr>
+          <p:cNvPr id="102" name="Google Shape;102;p16"/>
+          <p:cNvSpPr/>
+          <p:nvPr/>
+        </p:nvSpPr>
+        <p:spPr>
+          <a:xfrm>
+            <a:off x="658368" y="3986784"/>
+            <a:ext cx="7827264" cy="457200"/>
+          </a:xfrm>
+          <a:prstGeom prst="rect">
+            <a:avLst/>
+          </a:prstGeom>
+          <a:noFill/>
+          <a:ln>
+            <a:noFill/>
+          </a:ln>
+        </p:spPr>
+        <p:txBody>
+          <a:bodyPr anchorCtr="0" anchor="t" bIns="0" lIns="0" spcFirstLastPara="1" rIns="0" wrap="square" tIns="0">
+            <a:noAutofit/>
+          </a:bodyPr>
+          <a:lstStyle/>
+          <a:p>
+            <a:pPr indent="-152400" lvl="0" marL="152400" marR="0" rtl="0" algn="l">
+              <a:spcBef>
+                <a:spcPts val="0"/>
+              </a:spcBef>
+              <a:spcAft>
+                <a:spcPts val="400"/>
+              </a:spcAft>
+              <a:buClr>
+                <a:srgbClr val="00823D"/>
+              </a:buClr>
+              <a:buSzPts val="700"/>
+              <a:buFont typeface="Arial"/>
+              <a:buChar char="●"/>
+            </a:pPr>
+            <a:r>
+              <a:rPr b="1" i="0" lang="en" sz="800">
+                <a:solidFill>
+                  <a:srgbClr val="003726"/>
+                </a:solidFill>
+                <a:latin typeface="Arial"/>
+                <a:ea typeface="Arial"/>
+                <a:cs typeface="Arial"/>
+                <a:sym typeface="Arial"/>
               </a:rPr>
               <a:t>Microsoft IMBR:</a:t>
             </a:r>
             <a:r>
-              <a:rPr b="0" i="0" lang="en" sz="600" u="none" cap="none" strike="noStrike">
+              <a:rPr b="0" i="0" lang="en" sz="800">
                 <a:solidFill>
                   <a:srgbClr val="666666"/>
                 </a:solidFill>
-                <a:latin typeface="Inter"/>
-                <a:ea typeface="Inter"/>
-                <a:cs typeface="Inter"/>
-                <a:sym typeface="Inter"/>
+                <a:latin typeface="Arial"/>
+                <a:ea typeface="Arial"/>
+                <a:cs typeface="Arial"/>
+                <a:sym typeface="Arial"/>
               </a:rPr>
               <a:t> Retarget TV viewers with follow-up Search, Native, or Display ads</a:t>
             </a:r>
-            <a:endParaRPr b="0" i="0" sz="600" u="none" cap="none" strike="noStrike">
-              <a:solidFill>
-                <a:schemeClr val="dk1"/>
-              </a:solidFill>
-              <a:latin typeface="Arial"/>
-              <a:ea typeface="Arial"/>
-              <a:cs typeface="Arial"/>
-              <a:sym typeface="Arial"/>
-            </a:endParaRPr>
-          </a:p>
-          <a:p>
-            <a:pPr indent="-114300" lvl="0" marL="114300" marR="0" rtl="0" algn="l">
-              <a:lnSpc>
-                <a:spcPct val="101000"/>
-              </a:lnSpc>
+            <a:endParaRPr sz="800"/>
+          </a:p>
+          <a:p>
+            <a:pPr indent="-152400" lvl="0" marL="152400" marR="0" rtl="0" algn="l">
               <a:spcBef>
                 <a:spcPts val="0"/>
               </a:spcBef>
@@ -8027,45 +8846,37 @@
                 <a:spcPts val="0"/>
               </a:spcAft>
               <a:buClr>
-                <a:srgbClr val="666666"/>
+                <a:srgbClr val="00823D"/>
               </a:buClr>
-              <a:buSzPts val="600"/>
-              <a:buFont typeface="Inter"/>
-              <a:buChar char="•"/>
-            </a:pPr>
-            <a:r>
-              <a:rPr b="1" i="0" lang="en" sz="600" u="none" cap="none" strike="noStrike">
+              <a:buSzPts val="700"/>
+              <a:buFont typeface="Arial"/>
+              <a:buChar char="●"/>
+            </a:pPr>
+            <a:r>
+              <a:rPr b="1" i="0" lang="en" sz="800">
+                <a:solidFill>
+                  <a:srgbClr val="003726"/>
+                </a:solidFill>
+                <a:latin typeface="Arial"/>
+                <a:ea typeface="Arial"/>
+                <a:cs typeface="Arial"/>
+                <a:sym typeface="Arial"/>
+              </a:rPr>
+              <a:t>Google Demand Gen:</a:t>
+            </a:r>
+            <a:r>
+              <a:rPr b="0" i="0" lang="en" sz="800">
                 <a:solidFill>
                   <a:srgbClr val="666666"/>
                 </a:solidFill>
-                <a:latin typeface="Inter"/>
-                <a:ea typeface="Inter"/>
-                <a:cs typeface="Inter"/>
-                <a:sym typeface="Inter"/>
-              </a:rPr>
-              <a:t>Google Demand Gen:</a:t>
-            </a:r>
-            <a:r>
-              <a:rPr b="0" i="0" lang="en" sz="600" u="none" cap="none" strike="noStrike">
-                <a:solidFill>
-                  <a:srgbClr val="666666"/>
-                </a:solidFill>
-                <a:latin typeface="Inter"/>
-                <a:ea typeface="Inter"/>
-                <a:cs typeface="Inter"/>
-                <a:sym typeface="Inter"/>
+                <a:latin typeface="Arial"/>
+                <a:ea typeface="Arial"/>
+                <a:cs typeface="Arial"/>
+                <a:sym typeface="Arial"/>
               </a:rPr>
               <a:t> Re-engage warm streaming audiences across YouTube Shorts, Gmail, and Discover</a:t>
             </a:r>
-            <a:endParaRPr b="0" i="0" sz="600" u="none" cap="none" strike="noStrike">
-              <a:solidFill>
-                <a:schemeClr val="dk1"/>
-              </a:solidFill>
-              <a:latin typeface="Arial"/>
-              <a:ea typeface="Arial"/>
-              <a:cs typeface="Arial"/>
-              <a:sym typeface="Arial"/>
-            </a:endParaRPr>
+            <a:endParaRPr sz="800"/>
           </a:p>
         </p:txBody>
       </p:sp>
@@ -16504,7 +17315,7 @@
                 <a:cs typeface="Arial"/>
                 <a:sym typeface="Arial"/>
               </a:rPr>
-              <a:t>Cross Device</a:t>
+              <a:t>42+ inch TV Screens</a:t>
             </a:r>
             <a:endParaRPr sz="1500">
               <a:solidFill>

</xml_diff>

<commit_message>
Redraw slide 2 as a native circular cycle in the CAMP palette
Replaces the horizontal three-card flow with the circular cycle composition
of the original slide, but built from real shapes rather than a JPEG:

- three nodes on a triangle, each a white circle with a lime outline, a lime
  dotted ring, an outline icon and a forest heading over a gray caption
- clockwise arc connectors in forest with arrowheads, plus lime/green accent
  dots on the arcs and ring tops
- text blocks moved to a right rail: lime takeaway banner over a bordered card

Geometry is parameterised (R / RING / INNER / GAP) in slide2.py. Wording is
unchanged throughout.

Co-Authored-By: Claude Opus 5 <noreply@anthropic.com>
Claude-Session: https://claude.ai/code/session_01MShSkqRtrzZURyqLpqY9E5
</commit_message>
<xml_diff>
--- a/tri-peaks-camp-redesign/Tri_Peaks_Pitch_Test_CAMP_Design.pptx
+++ b/tri-peaks-camp-redesign/Tri_Peaks_Pitch_Test_CAMP_Design.pptx
@@ -7706,13 +7706,400 @@
         </p:nvSpPr>
         <p:spPr>
           <a:xfrm>
-            <a:off x="429768" y="932688"/>
-            <a:ext cx="2578608" cy="1389888"/>
-          </a:xfrm>
-          <a:prstGeom prst="roundRect">
+            <a:off x="1190291" y="1700784"/>
+            <a:ext cx="2706624" cy="2706624"/>
+          </a:xfrm>
+          <a:prstGeom prst="arc">
             <a:avLst>
-              <a:gd fmla="val 2799" name="adj"/>
+              <a:gd fmla="val 18480000" name="adj1"/>
+              <a:gd fmla="val 21120000" name="adj2"/>
             </a:avLst>
+          </a:prstGeom>
+          <a:noFill/>
+          <a:ln cap="flat" cmpd="sng" w="14300">
+            <a:solidFill>
+              <a:srgbClr val="003726"/>
+            </a:solidFill>
+            <a:prstDash val="solid"/>
+            <a:round/>
+            <a:headEnd len="sm" w="sm" type="none"/>
+            <a:tailEnd len="med" w="med" type="triangle"/>
+          </a:ln>
+        </p:spPr>
+        <p:txBody>
+          <a:bodyPr anchorCtr="0" anchor="t" bIns="0" lIns="0" spcFirstLastPara="1" rIns="0" wrap="square" tIns="0">
+            <a:noAutofit/>
+          </a:bodyPr>
+          <a:lstStyle/>
+          <a:p>
+            <a:pPr indent="0" lvl="0" marL="0" marR="0" rtl="0" algn="l">
+              <a:spcBef>
+                <a:spcPts val="0"/>
+              </a:spcBef>
+              <a:spcAft>
+                <a:spcPts val="0"/>
+              </a:spcAft>
+              <a:buNone/>
+            </a:pPr>
+            <a:r>
+              <a:rPr b="0" i="0" lang="en" sz="900">
+                <a:solidFill>
+                  <a:srgbClr val="666666"/>
+                </a:solidFill>
+                <a:latin typeface="Arial"/>
+                <a:ea typeface="Arial"/>
+                <a:cs typeface="Arial"/>
+                <a:sym typeface="Arial"/>
+              </a:rPr>
+              <a:t/>
+            </a:r>
+            <a:endParaRPr sz="900"/>
+          </a:p>
+        </p:txBody>
+      </p:sp>
+      <p:sp>
+        <p:nvSpPr>
+          <p:cNvPr id="83" name="Google Shape;83;p16"/>
+          <p:cNvSpPr/>
+          <p:nvPr/>
+        </p:nvSpPr>
+        <p:spPr>
+          <a:xfrm>
+            <a:off x="3665313" y="2327148"/>
+            <a:ext cx="100584" cy="100584"/>
+          </a:xfrm>
+          <a:prstGeom prst="ellipse">
+            <a:avLst/>
+          </a:prstGeom>
+          <a:solidFill>
+            <a:srgbClr val="00823D"/>
+          </a:solidFill>
+          <a:ln>
+            <a:noFill/>
+          </a:ln>
+        </p:spPr>
+        <p:txBody>
+          <a:bodyPr anchorCtr="0" anchor="t" bIns="0" lIns="0" spcFirstLastPara="1" rIns="0" wrap="square" tIns="0">
+            <a:noAutofit/>
+          </a:bodyPr>
+          <a:lstStyle/>
+          <a:p>
+            <a:pPr indent="0" lvl="0" marL="0" marR="0" rtl="0" algn="l">
+              <a:spcBef>
+                <a:spcPts val="0"/>
+              </a:spcBef>
+              <a:spcAft>
+                <a:spcPts val="0"/>
+              </a:spcAft>
+              <a:buNone/>
+            </a:pPr>
+            <a:r>
+              <a:rPr b="0" i="0" lang="en" sz="900">
+                <a:solidFill>
+                  <a:srgbClr val="666666"/>
+                </a:solidFill>
+                <a:latin typeface="Arial"/>
+                <a:ea typeface="Arial"/>
+                <a:cs typeface="Arial"/>
+                <a:sym typeface="Arial"/>
+              </a:rPr>
+              <a:t/>
+            </a:r>
+            <a:endParaRPr sz="900"/>
+          </a:p>
+        </p:txBody>
+      </p:sp>
+      <p:sp>
+        <p:nvSpPr>
+          <p:cNvPr id="84" name="Google Shape;84;p16"/>
+          <p:cNvSpPr/>
+          <p:nvPr/>
+        </p:nvSpPr>
+        <p:spPr>
+          <a:xfrm>
+            <a:off x="1190291" y="1700784"/>
+            <a:ext cx="2706624" cy="2706624"/>
+          </a:xfrm>
+          <a:prstGeom prst="arc">
+            <a:avLst>
+              <a:gd fmla="val 4080000" name="adj1"/>
+              <a:gd fmla="val 6720000" name="adj2"/>
+            </a:avLst>
+          </a:prstGeom>
+          <a:noFill/>
+          <a:ln cap="flat" cmpd="sng" w="14300">
+            <a:solidFill>
+              <a:srgbClr val="003726"/>
+            </a:solidFill>
+            <a:prstDash val="solid"/>
+            <a:round/>
+            <a:headEnd len="sm" w="sm" type="none"/>
+            <a:tailEnd len="med" w="med" type="triangle"/>
+          </a:ln>
+        </p:spPr>
+        <p:txBody>
+          <a:bodyPr anchorCtr="0" anchor="t" bIns="0" lIns="0" spcFirstLastPara="1" rIns="0" wrap="square" tIns="0">
+            <a:noAutofit/>
+          </a:bodyPr>
+          <a:lstStyle/>
+          <a:p>
+            <a:pPr indent="0" lvl="0" marL="0" marR="0" rtl="0" algn="l">
+              <a:spcBef>
+                <a:spcPts val="0"/>
+              </a:spcBef>
+              <a:spcAft>
+                <a:spcPts val="0"/>
+              </a:spcAft>
+              <a:buNone/>
+            </a:pPr>
+            <a:r>
+              <a:rPr b="0" i="0" lang="en" sz="900">
+                <a:solidFill>
+                  <a:srgbClr val="666666"/>
+                </a:solidFill>
+                <a:latin typeface="Arial"/>
+                <a:ea typeface="Arial"/>
+                <a:cs typeface="Arial"/>
+                <a:sym typeface="Arial"/>
+              </a:rPr>
+              <a:t/>
+            </a:r>
+            <a:endParaRPr sz="900"/>
+          </a:p>
+        </p:txBody>
+      </p:sp>
+      <p:sp>
+        <p:nvSpPr>
+          <p:cNvPr id="85" name="Google Shape;85;p16"/>
+          <p:cNvSpPr/>
+          <p:nvPr/>
+        </p:nvSpPr>
+        <p:spPr>
+          <a:xfrm>
+            <a:off x="2493311" y="4357116"/>
+            <a:ext cx="100584" cy="100584"/>
+          </a:xfrm>
+          <a:prstGeom prst="ellipse">
+            <a:avLst/>
+          </a:prstGeom>
+          <a:solidFill>
+            <a:srgbClr val="A7C142"/>
+          </a:solidFill>
+          <a:ln>
+            <a:noFill/>
+          </a:ln>
+        </p:spPr>
+        <p:txBody>
+          <a:bodyPr anchorCtr="0" anchor="t" bIns="0" lIns="0" spcFirstLastPara="1" rIns="0" wrap="square" tIns="0">
+            <a:noAutofit/>
+          </a:bodyPr>
+          <a:lstStyle/>
+          <a:p>
+            <a:pPr indent="0" lvl="0" marL="0" marR="0" rtl="0" algn="l">
+              <a:spcBef>
+                <a:spcPts val="0"/>
+              </a:spcBef>
+              <a:spcAft>
+                <a:spcPts val="0"/>
+              </a:spcAft>
+              <a:buNone/>
+            </a:pPr>
+            <a:r>
+              <a:rPr b="0" i="0" lang="en" sz="900">
+                <a:solidFill>
+                  <a:srgbClr val="666666"/>
+                </a:solidFill>
+                <a:latin typeface="Arial"/>
+                <a:ea typeface="Arial"/>
+                <a:cs typeface="Arial"/>
+                <a:sym typeface="Arial"/>
+              </a:rPr>
+              <a:t/>
+            </a:r>
+            <a:endParaRPr sz="900"/>
+          </a:p>
+        </p:txBody>
+      </p:sp>
+      <p:sp>
+        <p:nvSpPr>
+          <p:cNvPr id="86" name="Google Shape;86;p16"/>
+          <p:cNvSpPr/>
+          <p:nvPr/>
+        </p:nvSpPr>
+        <p:spPr>
+          <a:xfrm>
+            <a:off x="1190291" y="1700784"/>
+            <a:ext cx="2706624" cy="2706624"/>
+          </a:xfrm>
+          <a:prstGeom prst="arc">
+            <a:avLst>
+              <a:gd fmla="val 11280000" name="adj1"/>
+              <a:gd fmla="val 13920000" name="adj2"/>
+            </a:avLst>
+          </a:prstGeom>
+          <a:noFill/>
+          <a:ln cap="flat" cmpd="sng" w="14300">
+            <a:solidFill>
+              <a:srgbClr val="003726"/>
+            </a:solidFill>
+            <a:prstDash val="solid"/>
+            <a:round/>
+            <a:headEnd len="sm" w="sm" type="none"/>
+            <a:tailEnd len="med" w="med" type="triangle"/>
+          </a:ln>
+        </p:spPr>
+        <p:txBody>
+          <a:bodyPr anchorCtr="0" anchor="t" bIns="0" lIns="0" spcFirstLastPara="1" rIns="0" wrap="square" tIns="0">
+            <a:noAutofit/>
+          </a:bodyPr>
+          <a:lstStyle/>
+          <a:p>
+            <a:pPr indent="0" lvl="0" marL="0" marR="0" rtl="0" algn="l">
+              <a:spcBef>
+                <a:spcPts val="0"/>
+              </a:spcBef>
+              <a:spcAft>
+                <a:spcPts val="0"/>
+              </a:spcAft>
+              <a:buNone/>
+            </a:pPr>
+            <a:r>
+              <a:rPr b="0" i="0" lang="en" sz="900">
+                <a:solidFill>
+                  <a:srgbClr val="666666"/>
+                </a:solidFill>
+                <a:latin typeface="Arial"/>
+                <a:ea typeface="Arial"/>
+                <a:cs typeface="Arial"/>
+                <a:sym typeface="Arial"/>
+              </a:rPr>
+              <a:t/>
+            </a:r>
+            <a:endParaRPr sz="900"/>
+          </a:p>
+        </p:txBody>
+      </p:sp>
+      <p:sp>
+        <p:nvSpPr>
+          <p:cNvPr id="87" name="Google Shape;87;p16"/>
+          <p:cNvSpPr/>
+          <p:nvPr/>
+        </p:nvSpPr>
+        <p:spPr>
+          <a:xfrm>
+            <a:off x="1321308" y="2327148"/>
+            <a:ext cx="100584" cy="100584"/>
+          </a:xfrm>
+          <a:prstGeom prst="ellipse">
+            <a:avLst/>
+          </a:prstGeom>
+          <a:solidFill>
+            <a:srgbClr val="003726"/>
+          </a:solidFill>
+          <a:ln>
+            <a:noFill/>
+          </a:ln>
+        </p:spPr>
+        <p:txBody>
+          <a:bodyPr anchorCtr="0" anchor="t" bIns="0" lIns="0" spcFirstLastPara="1" rIns="0" wrap="square" tIns="0">
+            <a:noAutofit/>
+          </a:bodyPr>
+          <a:lstStyle/>
+          <a:p>
+            <a:pPr indent="0" lvl="0" marL="0" marR="0" rtl="0" algn="l">
+              <a:spcBef>
+                <a:spcPts val="0"/>
+              </a:spcBef>
+              <a:spcAft>
+                <a:spcPts val="0"/>
+              </a:spcAft>
+              <a:buNone/>
+            </a:pPr>
+            <a:r>
+              <a:rPr b="0" i="0" lang="en" sz="900">
+                <a:solidFill>
+                  <a:srgbClr val="666666"/>
+                </a:solidFill>
+                <a:latin typeface="Arial"/>
+                <a:ea typeface="Arial"/>
+                <a:cs typeface="Arial"/>
+                <a:sym typeface="Arial"/>
+              </a:rPr>
+              <a:t/>
+            </a:r>
+            <a:endParaRPr sz="900"/>
+          </a:p>
+        </p:txBody>
+      </p:sp>
+      <p:sp>
+        <p:nvSpPr>
+          <p:cNvPr id="88" name="Google Shape;88;p16"/>
+          <p:cNvSpPr/>
+          <p:nvPr/>
+        </p:nvSpPr>
+        <p:spPr>
+          <a:xfrm>
+            <a:off x="1720643" y="877824"/>
+            <a:ext cx="1645920" cy="1645920"/>
+          </a:xfrm>
+          <a:prstGeom prst="ellipse">
+            <a:avLst/>
+          </a:prstGeom>
+          <a:noFill/>
+          <a:ln cap="flat" cmpd="sng" w="9525">
+            <a:solidFill>
+              <a:srgbClr val="A7C142"/>
+            </a:solidFill>
+            <a:prstDash val="sysDot"/>
+            <a:round/>
+            <a:headEnd len="sm" w="sm" type="none"/>
+            <a:tailEnd len="sm" w="sm" type="none"/>
+          </a:ln>
+        </p:spPr>
+        <p:txBody>
+          <a:bodyPr anchorCtr="0" anchor="t" bIns="0" lIns="0" spcFirstLastPara="1" rIns="0" wrap="square" tIns="0">
+            <a:noAutofit/>
+          </a:bodyPr>
+          <a:lstStyle/>
+          <a:p>
+            <a:pPr indent="0" lvl="0" marL="0" marR="0" rtl="0" algn="l">
+              <a:spcBef>
+                <a:spcPts val="0"/>
+              </a:spcBef>
+              <a:spcAft>
+                <a:spcPts val="0"/>
+              </a:spcAft>
+              <a:buNone/>
+            </a:pPr>
+            <a:r>
+              <a:rPr b="0" i="0" lang="en" sz="900">
+                <a:solidFill>
+                  <a:srgbClr val="666666"/>
+                </a:solidFill>
+                <a:latin typeface="Arial"/>
+                <a:ea typeface="Arial"/>
+                <a:cs typeface="Arial"/>
+                <a:sym typeface="Arial"/>
+              </a:rPr>
+              <a:t/>
+            </a:r>
+            <a:endParaRPr sz="900"/>
+          </a:p>
+        </p:txBody>
+      </p:sp>
+      <p:sp>
+        <p:nvSpPr>
+          <p:cNvPr id="89" name="Google Shape;89;p16"/>
+          <p:cNvSpPr/>
+          <p:nvPr/>
+        </p:nvSpPr>
+        <p:spPr>
+          <a:xfrm>
+            <a:off x="1812083" y="969264"/>
+            <a:ext cx="1463040" cy="1463040"/>
+          </a:xfrm>
+          <a:prstGeom prst="ellipse">
+            <a:avLst/>
           </a:prstGeom>
           <a:solidFill>
             <a:srgbClr val="FFFFFF"/>
@@ -7760,14 +8147,14 @@
       </p:sp>
       <p:sp>
         <p:nvSpPr>
-          <p:cNvPr id="83" name="Google Shape;83;p16"/>
-          <p:cNvSpPr/>
-          <p:nvPr/>
-        </p:nvSpPr>
-        <p:spPr>
-          <a:xfrm>
-            <a:off x="1636776" y="1170432"/>
-            <a:ext cx="164592" cy="164592"/>
+          <p:cNvPr id="90" name="Google Shape;90;p16"/>
+          <p:cNvSpPr/>
+          <p:nvPr/>
+        </p:nvSpPr>
+        <p:spPr>
+          <a:xfrm>
+            <a:off x="2493311" y="827532"/>
+            <a:ext cx="100584" cy="100584"/>
           </a:xfrm>
           <a:prstGeom prst="ellipse">
             <a:avLst/>
@@ -7812,129 +8199,27 @@
       </p:sp>
       <p:sp>
         <p:nvSpPr>
-          <p:cNvPr id="84" name="Google Shape;84;p16"/>
-          <p:cNvSpPr/>
-          <p:nvPr/>
-        </p:nvSpPr>
-        <p:spPr>
-          <a:xfrm>
-            <a:off x="576072" y="1389888"/>
-            <a:ext cx="2286000" cy="402336"/>
-          </a:xfrm>
-          <a:prstGeom prst="rect">
+          <p:cNvPr id="91" name="Google Shape;91;p16"/>
+          <p:cNvSpPr/>
+          <p:nvPr/>
+        </p:nvSpPr>
+        <p:spPr>
+          <a:xfrm>
+            <a:off x="2406443" y="1133856"/>
+            <a:ext cx="274320" cy="274320"/>
+          </a:xfrm>
+          <a:prstGeom prst="diamond">
             <a:avLst/>
           </a:prstGeom>
           <a:noFill/>
-          <a:ln>
-            <a:noFill/>
-          </a:ln>
-        </p:spPr>
-        <p:txBody>
-          <a:bodyPr anchorCtr="0" anchor="b" bIns="0" lIns="0" spcFirstLastPara="1" rIns="0" wrap="square" tIns="0">
-            <a:noAutofit/>
-          </a:bodyPr>
-          <a:lstStyle/>
-          <a:p>
-            <a:pPr indent="0" lvl="0" marL="0" marR="0" rtl="0" algn="ctr">
-              <a:lnSpc>
-                <a:spcPct val="100000"/>
-              </a:lnSpc>
-              <a:spcBef>
-                <a:spcPts val="0"/>
-              </a:spcBef>
-              <a:spcAft>
-                <a:spcPts val="0"/>
-              </a:spcAft>
-              <a:buNone/>
-            </a:pPr>
-            <a:r>
-              <a:rPr b="1" i="0" lang="en" sz="1100">
-                <a:solidFill>
-                  <a:srgbClr val="003726"/>
-                </a:solidFill>
-                <a:latin typeface="Arial"/>
-                <a:ea typeface="Arial"/>
-                <a:cs typeface="Arial"/>
-                <a:sym typeface="Arial"/>
-              </a:rPr>
-              <a:t>CTV Awareness</a:t>
-            </a:r>
-            <a:endParaRPr sz="1100"/>
-          </a:p>
-        </p:txBody>
-      </p:sp>
-      <p:sp>
-        <p:nvSpPr>
-          <p:cNvPr id="85" name="Google Shape;85;p16"/>
-          <p:cNvSpPr/>
-          <p:nvPr/>
-        </p:nvSpPr>
-        <p:spPr>
-          <a:xfrm>
-            <a:off x="576072" y="1819656"/>
-            <a:ext cx="2286000" cy="420624"/>
-          </a:xfrm>
-          <a:prstGeom prst="rect">
-            <a:avLst/>
-          </a:prstGeom>
-          <a:noFill/>
-          <a:ln>
-            <a:noFill/>
-          </a:ln>
-        </p:spPr>
-        <p:txBody>
-          <a:bodyPr anchorCtr="0" anchor="t" bIns="0" lIns="0" spcFirstLastPara="1" rIns="0" wrap="square" tIns="0">
-            <a:noAutofit/>
-          </a:bodyPr>
-          <a:lstStyle/>
-          <a:p>
-            <a:pPr indent="0" lvl="0" marL="0" marR="0" rtl="0" algn="ctr">
-              <a:lnSpc>
-                <a:spcPct val="100000"/>
-              </a:lnSpc>
-              <a:spcBef>
-                <a:spcPts val="0"/>
-              </a:spcBef>
-              <a:spcAft>
-                <a:spcPts val="0"/>
-              </a:spcAft>
-              <a:buNone/>
-            </a:pPr>
-            <a:r>
-              <a:rPr b="0" i="0" lang="en" sz="800">
-                <a:solidFill>
-                  <a:srgbClr val="666666"/>
-                </a:solidFill>
-                <a:latin typeface="Arial"/>
-                <a:ea typeface="Arial"/>
-                <a:cs typeface="Arial"/>
-                <a:sym typeface="Arial"/>
-              </a:rPr>
-              <a:t>(top-of-mind brand trust on living room screens)</a:t>
-            </a:r>
-            <a:endParaRPr sz="800"/>
-          </a:p>
-        </p:txBody>
-      </p:sp>
-      <p:sp>
-        <p:nvSpPr>
-          <p:cNvPr id="86" name="Google Shape;86;p16"/>
-          <p:cNvSpPr/>
-          <p:nvPr/>
-        </p:nvSpPr>
-        <p:spPr>
-          <a:xfrm rot="5400000">
-            <a:off x="3063240" y="1536192"/>
-            <a:ext cx="164592" cy="182880"/>
-          </a:xfrm>
-          <a:prstGeom prst="triangle">
-            <a:avLst/>
-          </a:prstGeom>
-          <a:solidFill>
-            <a:srgbClr val="A7C142"/>
-          </a:solidFill>
-          <a:ln>
-            <a:noFill/>
+          <a:ln cap="flat" cmpd="sng" w="9525">
+            <a:solidFill>
+              <a:srgbClr val="003726"/>
+            </a:solidFill>
+            <a:prstDash val="solid"/>
+            <a:round/>
+            <a:headEnd len="sm" w="sm" type="none"/>
+            <a:tailEnd len="sm" w="sm" type="none"/>
           </a:ln>
         </p:spPr>
         <p:txBody>
@@ -7970,19 +8255,179 @@
       </p:sp>
       <p:sp>
         <p:nvSpPr>
-          <p:cNvPr id="87" name="Google Shape;87;p16"/>
-          <p:cNvSpPr/>
-          <p:nvPr/>
-        </p:nvSpPr>
-        <p:spPr>
-          <a:xfrm>
-            <a:off x="3282696" y="932688"/>
-            <a:ext cx="2578608" cy="1389888"/>
-          </a:xfrm>
-          <a:prstGeom prst="roundRect">
-            <a:avLst>
-              <a:gd fmla="val 2799" name="adj"/>
-            </a:avLst>
+          <p:cNvPr id="92" name="Google Shape;92;p16"/>
+          <p:cNvSpPr/>
+          <p:nvPr/>
+        </p:nvSpPr>
+        <p:spPr>
+          <a:xfrm>
+            <a:off x="1894379" y="1426464"/>
+            <a:ext cx="1298448" cy="420624"/>
+          </a:xfrm>
+          <a:prstGeom prst="rect">
+            <a:avLst/>
+          </a:prstGeom>
+          <a:noFill/>
+          <a:ln>
+            <a:noFill/>
+          </a:ln>
+        </p:spPr>
+        <p:txBody>
+          <a:bodyPr anchorCtr="0" anchor="b" bIns="0" lIns="0" spcFirstLastPara="1" rIns="0" wrap="square" tIns="0">
+            <a:noAutofit/>
+          </a:bodyPr>
+          <a:lstStyle/>
+          <a:p>
+            <a:pPr indent="0" lvl="0" marL="0" marR="0" rtl="0" algn="ctr">
+              <a:lnSpc>
+                <a:spcPct val="100000"/>
+              </a:lnSpc>
+              <a:spcBef>
+                <a:spcPts val="0"/>
+              </a:spcBef>
+              <a:spcAft>
+                <a:spcPts val="0"/>
+              </a:spcAft>
+              <a:buNone/>
+            </a:pPr>
+            <a:r>
+              <a:rPr b="1" i="0" lang="en" sz="800">
+                <a:solidFill>
+                  <a:srgbClr val="003726"/>
+                </a:solidFill>
+                <a:latin typeface="Arial"/>
+                <a:ea typeface="Arial"/>
+                <a:cs typeface="Arial"/>
+                <a:sym typeface="Arial"/>
+              </a:rPr>
+              <a:t>CTV Awareness</a:t>
+            </a:r>
+            <a:endParaRPr sz="800"/>
+          </a:p>
+        </p:txBody>
+      </p:sp>
+      <p:sp>
+        <p:nvSpPr>
+          <p:cNvPr id="93" name="Google Shape;93;p16"/>
+          <p:cNvSpPr/>
+          <p:nvPr/>
+        </p:nvSpPr>
+        <p:spPr>
+          <a:xfrm>
+            <a:off x="1967531" y="1865376"/>
+            <a:ext cx="1152144" cy="347472"/>
+          </a:xfrm>
+          <a:prstGeom prst="rect">
+            <a:avLst/>
+          </a:prstGeom>
+          <a:noFill/>
+          <a:ln>
+            <a:noFill/>
+          </a:ln>
+        </p:spPr>
+        <p:txBody>
+          <a:bodyPr anchorCtr="0" anchor="t" bIns="0" lIns="0" spcFirstLastPara="1" rIns="0" wrap="square" tIns="0">
+            <a:noAutofit/>
+          </a:bodyPr>
+          <a:lstStyle/>
+          <a:p>
+            <a:pPr indent="0" lvl="0" marL="0" marR="0" rtl="0" algn="ctr">
+              <a:lnSpc>
+                <a:spcPct val="100000"/>
+              </a:lnSpc>
+              <a:spcBef>
+                <a:spcPts val="0"/>
+              </a:spcBef>
+              <a:spcAft>
+                <a:spcPts val="0"/>
+              </a:spcAft>
+              <a:buNone/>
+            </a:pPr>
+            <a:r>
+              <a:rPr b="0" i="0" lang="en" sz="700">
+                <a:solidFill>
+                  <a:srgbClr val="666666"/>
+                </a:solidFill>
+                <a:latin typeface="Arial"/>
+                <a:ea typeface="Arial"/>
+                <a:cs typeface="Arial"/>
+                <a:sym typeface="Arial"/>
+              </a:rPr>
+              <a:t>(top-of-mind brand trust on living room screens)</a:t>
+            </a:r>
+            <a:endParaRPr sz="700"/>
+          </a:p>
+        </p:txBody>
+      </p:sp>
+      <p:sp>
+        <p:nvSpPr>
+          <p:cNvPr id="94" name="Google Shape;94;p16"/>
+          <p:cNvSpPr/>
+          <p:nvPr/>
+        </p:nvSpPr>
+        <p:spPr>
+          <a:xfrm>
+            <a:off x="2892645" y="2907792"/>
+            <a:ext cx="1645920" cy="1645920"/>
+          </a:xfrm>
+          <a:prstGeom prst="ellipse">
+            <a:avLst/>
+          </a:prstGeom>
+          <a:noFill/>
+          <a:ln cap="flat" cmpd="sng" w="9525">
+            <a:solidFill>
+              <a:srgbClr val="A7C142"/>
+            </a:solidFill>
+            <a:prstDash val="sysDot"/>
+            <a:round/>
+            <a:headEnd len="sm" w="sm" type="none"/>
+            <a:tailEnd len="sm" w="sm" type="none"/>
+          </a:ln>
+        </p:spPr>
+        <p:txBody>
+          <a:bodyPr anchorCtr="0" anchor="t" bIns="0" lIns="0" spcFirstLastPara="1" rIns="0" wrap="square" tIns="0">
+            <a:noAutofit/>
+          </a:bodyPr>
+          <a:lstStyle/>
+          <a:p>
+            <a:pPr indent="0" lvl="0" marL="0" marR="0" rtl="0" algn="l">
+              <a:spcBef>
+                <a:spcPts val="0"/>
+              </a:spcBef>
+              <a:spcAft>
+                <a:spcPts val="0"/>
+              </a:spcAft>
+              <a:buNone/>
+            </a:pPr>
+            <a:r>
+              <a:rPr b="0" i="0" lang="en" sz="900">
+                <a:solidFill>
+                  <a:srgbClr val="666666"/>
+                </a:solidFill>
+                <a:latin typeface="Arial"/>
+                <a:ea typeface="Arial"/>
+                <a:cs typeface="Arial"/>
+                <a:sym typeface="Arial"/>
+              </a:rPr>
+              <a:t/>
+            </a:r>
+            <a:endParaRPr sz="900"/>
+          </a:p>
+        </p:txBody>
+      </p:sp>
+      <p:sp>
+        <p:nvSpPr>
+          <p:cNvPr id="95" name="Google Shape;95;p16"/>
+          <p:cNvSpPr/>
+          <p:nvPr/>
+        </p:nvSpPr>
+        <p:spPr>
+          <a:xfrm>
+            <a:off x="2984085" y="2999232"/>
+            <a:ext cx="1463040" cy="1463040"/>
+          </a:xfrm>
+          <a:prstGeom prst="ellipse">
+            <a:avLst/>
           </a:prstGeom>
           <a:solidFill>
             <a:srgbClr val="FFFFFF"/>
@@ -8030,20 +8475,20 @@
       </p:sp>
       <p:sp>
         <p:nvSpPr>
-          <p:cNvPr id="88" name="Google Shape;88;p16"/>
-          <p:cNvSpPr/>
-          <p:nvPr/>
-        </p:nvSpPr>
-        <p:spPr>
-          <a:xfrm>
-            <a:off x="4489704" y="1170432"/>
-            <a:ext cx="164592" cy="164592"/>
+          <p:cNvPr id="96" name="Google Shape;96;p16"/>
+          <p:cNvSpPr/>
+          <p:nvPr/>
+        </p:nvSpPr>
+        <p:spPr>
+          <a:xfrm>
+            <a:off x="3665313" y="2857500"/>
+            <a:ext cx="100584" cy="100584"/>
           </a:xfrm>
           <a:prstGeom prst="ellipse">
             <a:avLst/>
           </a:prstGeom>
           <a:solidFill>
-            <a:srgbClr val="A7C142"/>
+            <a:srgbClr val="003726"/>
           </a:solidFill>
           <a:ln>
             <a:noFill/>
@@ -8082,129 +8527,27 @@
       </p:sp>
       <p:sp>
         <p:nvSpPr>
-          <p:cNvPr id="89" name="Google Shape;89;p16"/>
-          <p:cNvSpPr/>
-          <p:nvPr/>
-        </p:nvSpPr>
-        <p:spPr>
-          <a:xfrm>
-            <a:off x="3429000" y="1389888"/>
-            <a:ext cx="2286000" cy="402336"/>
-          </a:xfrm>
-          <a:prstGeom prst="rect">
+          <p:cNvPr id="97" name="Google Shape;97;p16"/>
+          <p:cNvSpPr/>
+          <p:nvPr/>
+        </p:nvSpPr>
+        <p:spPr>
+          <a:xfrm>
+            <a:off x="3578445" y="3163824"/>
+            <a:ext cx="274320" cy="274320"/>
+          </a:xfrm>
+          <a:prstGeom prst="hexagon">
             <a:avLst/>
           </a:prstGeom>
           <a:noFill/>
-          <a:ln>
-            <a:noFill/>
-          </a:ln>
-        </p:spPr>
-        <p:txBody>
-          <a:bodyPr anchorCtr="0" anchor="b" bIns="0" lIns="0" spcFirstLastPara="1" rIns="0" wrap="square" tIns="0">
-            <a:noAutofit/>
-          </a:bodyPr>
-          <a:lstStyle/>
-          <a:p>
-            <a:pPr indent="0" lvl="0" marL="0" marR="0" rtl="0" algn="ctr">
-              <a:lnSpc>
-                <a:spcPct val="100000"/>
-              </a:lnSpc>
-              <a:spcBef>
-                <a:spcPts val="0"/>
-              </a:spcBef>
-              <a:spcAft>
-                <a:spcPts val="0"/>
-              </a:spcAft>
-              <a:buNone/>
-            </a:pPr>
-            <a:r>
-              <a:rPr b="1" i="0" lang="en" sz="1100">
-                <a:solidFill>
-                  <a:srgbClr val="003726"/>
-                </a:solidFill>
-                <a:latin typeface="Arial"/>
-                <a:ea typeface="Arial"/>
-                <a:cs typeface="Arial"/>
-                <a:sym typeface="Arial"/>
-              </a:rPr>
-              <a:t>Branded Searches</a:t>
-            </a:r>
-            <a:endParaRPr sz="1100"/>
-          </a:p>
-        </p:txBody>
-      </p:sp>
-      <p:sp>
-        <p:nvSpPr>
-          <p:cNvPr id="90" name="Google Shape;90;p16"/>
-          <p:cNvSpPr/>
-          <p:nvPr/>
-        </p:nvSpPr>
-        <p:spPr>
-          <a:xfrm>
-            <a:off x="3429000" y="1819656"/>
-            <a:ext cx="2286000" cy="420624"/>
-          </a:xfrm>
-          <a:prstGeom prst="rect">
-            <a:avLst/>
-          </a:prstGeom>
-          <a:noFill/>
-          <a:ln>
-            <a:noFill/>
-          </a:ln>
-        </p:spPr>
-        <p:txBody>
-          <a:bodyPr anchorCtr="0" anchor="t" bIns="0" lIns="0" spcFirstLastPara="1" rIns="0" wrap="square" tIns="0">
-            <a:noAutofit/>
-          </a:bodyPr>
-          <a:lstStyle/>
-          <a:p>
-            <a:pPr indent="0" lvl="0" marL="0" marR="0" rtl="0" algn="ctr">
-              <a:lnSpc>
-                <a:spcPct val="100000"/>
-              </a:lnSpc>
-              <a:spcBef>
-                <a:spcPts val="0"/>
-              </a:spcBef>
-              <a:spcAft>
-                <a:spcPts val="0"/>
-              </a:spcAft>
-              <a:buNone/>
-            </a:pPr>
-            <a:r>
-              <a:rPr b="0" i="0" lang="en" sz="800">
-                <a:solidFill>
-                  <a:srgbClr val="666666"/>
-                </a:solidFill>
-                <a:latin typeface="Arial"/>
-                <a:ea typeface="Arial"/>
-                <a:cs typeface="Arial"/>
-                <a:sym typeface="Arial"/>
-              </a:rPr>
-              <a:t>(homeowners search your name directly)</a:t>
-            </a:r>
-            <a:endParaRPr sz="800"/>
-          </a:p>
-        </p:txBody>
-      </p:sp>
-      <p:sp>
-        <p:nvSpPr>
-          <p:cNvPr id="91" name="Google Shape;91;p16"/>
-          <p:cNvSpPr/>
-          <p:nvPr/>
-        </p:nvSpPr>
-        <p:spPr>
-          <a:xfrm rot="5400000">
-            <a:off x="5916168" y="1536192"/>
-            <a:ext cx="164592" cy="182880"/>
-          </a:xfrm>
-          <a:prstGeom prst="triangle">
-            <a:avLst/>
-          </a:prstGeom>
-          <a:solidFill>
-            <a:srgbClr val="A7C142"/>
-          </a:solidFill>
-          <a:ln>
-            <a:noFill/>
+          <a:ln cap="flat" cmpd="sng" w="9525">
+            <a:solidFill>
+              <a:srgbClr val="003726"/>
+            </a:solidFill>
+            <a:prstDash val="solid"/>
+            <a:round/>
+            <a:headEnd len="sm" w="sm" type="none"/>
+            <a:tailEnd len="sm" w="sm" type="none"/>
           </a:ln>
         </p:spPr>
         <p:txBody>
@@ -8240,19 +8583,179 @@
       </p:sp>
       <p:sp>
         <p:nvSpPr>
-          <p:cNvPr id="92" name="Google Shape;92;p16"/>
-          <p:cNvSpPr/>
-          <p:nvPr/>
-        </p:nvSpPr>
-        <p:spPr>
-          <a:xfrm>
-            <a:off x="6135624" y="932688"/>
-            <a:ext cx="2578608" cy="1389888"/>
-          </a:xfrm>
-          <a:prstGeom prst="roundRect">
-            <a:avLst>
-              <a:gd fmla="val 2799" name="adj"/>
-            </a:avLst>
+          <p:cNvPr id="98" name="Google Shape;98;p16"/>
+          <p:cNvSpPr/>
+          <p:nvPr/>
+        </p:nvSpPr>
+        <p:spPr>
+          <a:xfrm>
+            <a:off x="3066381" y="3456432"/>
+            <a:ext cx="1298448" cy="420624"/>
+          </a:xfrm>
+          <a:prstGeom prst="rect">
+            <a:avLst/>
+          </a:prstGeom>
+          <a:noFill/>
+          <a:ln>
+            <a:noFill/>
+          </a:ln>
+        </p:spPr>
+        <p:txBody>
+          <a:bodyPr anchorCtr="0" anchor="b" bIns="0" lIns="0" spcFirstLastPara="1" rIns="0" wrap="square" tIns="0">
+            <a:noAutofit/>
+          </a:bodyPr>
+          <a:lstStyle/>
+          <a:p>
+            <a:pPr indent="0" lvl="0" marL="0" marR="0" rtl="0" algn="ctr">
+              <a:lnSpc>
+                <a:spcPct val="100000"/>
+              </a:lnSpc>
+              <a:spcBef>
+                <a:spcPts val="0"/>
+              </a:spcBef>
+              <a:spcAft>
+                <a:spcPts val="0"/>
+              </a:spcAft>
+              <a:buNone/>
+            </a:pPr>
+            <a:r>
+              <a:rPr b="1" i="0" lang="en" sz="800">
+                <a:solidFill>
+                  <a:srgbClr val="003726"/>
+                </a:solidFill>
+                <a:latin typeface="Arial"/>
+                <a:ea typeface="Arial"/>
+                <a:cs typeface="Arial"/>
+                <a:sym typeface="Arial"/>
+              </a:rPr>
+              <a:t>Branded Searches</a:t>
+            </a:r>
+            <a:endParaRPr sz="800"/>
+          </a:p>
+        </p:txBody>
+      </p:sp>
+      <p:sp>
+        <p:nvSpPr>
+          <p:cNvPr id="99" name="Google Shape;99;p16"/>
+          <p:cNvSpPr/>
+          <p:nvPr/>
+        </p:nvSpPr>
+        <p:spPr>
+          <a:xfrm>
+            <a:off x="3139533" y="3895344"/>
+            <a:ext cx="1152144" cy="347472"/>
+          </a:xfrm>
+          <a:prstGeom prst="rect">
+            <a:avLst/>
+          </a:prstGeom>
+          <a:noFill/>
+          <a:ln>
+            <a:noFill/>
+          </a:ln>
+        </p:spPr>
+        <p:txBody>
+          <a:bodyPr anchorCtr="0" anchor="t" bIns="0" lIns="0" spcFirstLastPara="1" rIns="0" wrap="square" tIns="0">
+            <a:noAutofit/>
+          </a:bodyPr>
+          <a:lstStyle/>
+          <a:p>
+            <a:pPr indent="0" lvl="0" marL="0" marR="0" rtl="0" algn="ctr">
+              <a:lnSpc>
+                <a:spcPct val="100000"/>
+              </a:lnSpc>
+              <a:spcBef>
+                <a:spcPts val="0"/>
+              </a:spcBef>
+              <a:spcAft>
+                <a:spcPts val="0"/>
+              </a:spcAft>
+              <a:buNone/>
+            </a:pPr>
+            <a:r>
+              <a:rPr b="0" i="0" lang="en" sz="700">
+                <a:solidFill>
+                  <a:srgbClr val="666666"/>
+                </a:solidFill>
+                <a:latin typeface="Arial"/>
+                <a:ea typeface="Arial"/>
+                <a:cs typeface="Arial"/>
+                <a:sym typeface="Arial"/>
+              </a:rPr>
+              <a:t>(homeowners search your name directly)</a:t>
+            </a:r>
+            <a:endParaRPr sz="700"/>
+          </a:p>
+        </p:txBody>
+      </p:sp>
+      <p:sp>
+        <p:nvSpPr>
+          <p:cNvPr id="100" name="Google Shape;100;p16"/>
+          <p:cNvSpPr/>
+          <p:nvPr/>
+        </p:nvSpPr>
+        <p:spPr>
+          <a:xfrm>
+            <a:off x="548640" y="2907792"/>
+            <a:ext cx="1645920" cy="1645920"/>
+          </a:xfrm>
+          <a:prstGeom prst="ellipse">
+            <a:avLst/>
+          </a:prstGeom>
+          <a:noFill/>
+          <a:ln cap="flat" cmpd="sng" w="9525">
+            <a:solidFill>
+              <a:srgbClr val="A7C142"/>
+            </a:solidFill>
+            <a:prstDash val="sysDot"/>
+            <a:round/>
+            <a:headEnd len="sm" w="sm" type="none"/>
+            <a:tailEnd len="sm" w="sm" type="none"/>
+          </a:ln>
+        </p:spPr>
+        <p:txBody>
+          <a:bodyPr anchorCtr="0" anchor="t" bIns="0" lIns="0" spcFirstLastPara="1" rIns="0" wrap="square" tIns="0">
+            <a:noAutofit/>
+          </a:bodyPr>
+          <a:lstStyle/>
+          <a:p>
+            <a:pPr indent="0" lvl="0" marL="0" marR="0" rtl="0" algn="l">
+              <a:spcBef>
+                <a:spcPts val="0"/>
+              </a:spcBef>
+              <a:spcAft>
+                <a:spcPts val="0"/>
+              </a:spcAft>
+              <a:buNone/>
+            </a:pPr>
+            <a:r>
+              <a:rPr b="0" i="0" lang="en" sz="900">
+                <a:solidFill>
+                  <a:srgbClr val="666666"/>
+                </a:solidFill>
+                <a:latin typeface="Arial"/>
+                <a:ea typeface="Arial"/>
+                <a:cs typeface="Arial"/>
+                <a:sym typeface="Arial"/>
+              </a:rPr>
+              <a:t/>
+            </a:r>
+            <a:endParaRPr sz="900"/>
+          </a:p>
+        </p:txBody>
+      </p:sp>
+      <p:sp>
+        <p:nvSpPr>
+          <p:cNvPr id="101" name="Google Shape;101;p16"/>
+          <p:cNvSpPr/>
+          <p:nvPr/>
+        </p:nvSpPr>
+        <p:spPr>
+          <a:xfrm>
+            <a:off x="640080" y="2999232"/>
+            <a:ext cx="1463040" cy="1463040"/>
+          </a:xfrm>
+          <a:prstGeom prst="ellipse">
+            <a:avLst/>
           </a:prstGeom>
           <a:solidFill>
             <a:srgbClr val="FFFFFF"/>
@@ -8300,20 +8803,20 @@
       </p:sp>
       <p:sp>
         <p:nvSpPr>
-          <p:cNvPr id="93" name="Google Shape;93;p16"/>
-          <p:cNvSpPr/>
-          <p:nvPr/>
-        </p:nvSpPr>
-        <p:spPr>
-          <a:xfrm>
-            <a:off x="7342632" y="1170432"/>
-            <a:ext cx="164592" cy="164592"/>
+          <p:cNvPr id="102" name="Google Shape;102;p16"/>
+          <p:cNvSpPr/>
+          <p:nvPr/>
+        </p:nvSpPr>
+        <p:spPr>
+          <a:xfrm>
+            <a:off x="1321308" y="2857500"/>
+            <a:ext cx="100584" cy="100584"/>
           </a:xfrm>
           <a:prstGeom prst="ellipse">
             <a:avLst/>
           </a:prstGeom>
           <a:solidFill>
-            <a:srgbClr val="A7C142"/>
+            <a:srgbClr val="00823D"/>
           </a:solidFill>
           <a:ln>
             <a:noFill/>
@@ -8352,129 +8855,27 @@
       </p:sp>
       <p:sp>
         <p:nvSpPr>
-          <p:cNvPr id="94" name="Google Shape;94;p16"/>
-          <p:cNvSpPr/>
-          <p:nvPr/>
-        </p:nvSpPr>
-        <p:spPr>
-          <a:xfrm>
-            <a:off x="6281928" y="1389888"/>
-            <a:ext cx="2286000" cy="402336"/>
-          </a:xfrm>
-          <a:prstGeom prst="rect">
+          <p:cNvPr id="103" name="Google Shape;103;p16"/>
+          <p:cNvSpPr/>
+          <p:nvPr/>
+        </p:nvSpPr>
+        <p:spPr>
+          <a:xfrm>
+            <a:off x="1234440" y="3163824"/>
+            <a:ext cx="274320" cy="274320"/>
+          </a:xfrm>
+          <a:prstGeom prst="triangle">
             <a:avLst/>
           </a:prstGeom>
           <a:noFill/>
-          <a:ln>
-            <a:noFill/>
-          </a:ln>
-        </p:spPr>
-        <p:txBody>
-          <a:bodyPr anchorCtr="0" anchor="b" bIns="0" lIns="0" spcFirstLastPara="1" rIns="0" wrap="square" tIns="0">
-            <a:noAutofit/>
-          </a:bodyPr>
-          <a:lstStyle/>
-          <a:p>
-            <a:pPr indent="0" lvl="0" marL="0" marR="0" rtl="0" algn="ctr">
-              <a:lnSpc>
-                <a:spcPct val="100000"/>
-              </a:lnSpc>
-              <a:spcBef>
-                <a:spcPts val="0"/>
-              </a:spcBef>
-              <a:spcAft>
-                <a:spcPts val="0"/>
-              </a:spcAft>
-              <a:buNone/>
-            </a:pPr>
-            <a:r>
-              <a:rPr b="1" i="0" lang="en" sz="1100">
-                <a:solidFill>
-                  <a:srgbClr val="003726"/>
-                </a:solidFill>
-                <a:latin typeface="Arial"/>
-                <a:ea typeface="Arial"/>
-                <a:cs typeface="Arial"/>
-                <a:sym typeface="Arial"/>
-              </a:rPr>
-              <a:t>Lower CPL and Higher PPC Conversion Rates</a:t>
-            </a:r>
-            <a:endParaRPr sz="1100"/>
-          </a:p>
-        </p:txBody>
-      </p:sp>
-      <p:sp>
-        <p:nvSpPr>
-          <p:cNvPr id="95" name="Google Shape;95;p16"/>
-          <p:cNvSpPr/>
-          <p:nvPr/>
-        </p:nvSpPr>
-        <p:spPr>
-          <a:xfrm>
-            <a:off x="6281928" y="1819656"/>
-            <a:ext cx="2286000" cy="420624"/>
-          </a:xfrm>
-          <a:prstGeom prst="rect">
-            <a:avLst/>
-          </a:prstGeom>
-          <a:noFill/>
-          <a:ln>
-            <a:noFill/>
-          </a:ln>
-        </p:spPr>
-        <p:txBody>
-          <a:bodyPr anchorCtr="0" anchor="t" bIns="0" lIns="0" spcFirstLastPara="1" rIns="0" wrap="square" tIns="0">
-            <a:noAutofit/>
-          </a:bodyPr>
-          <a:lstStyle/>
-          <a:p>
-            <a:pPr indent="0" lvl="0" marL="0" marR="0" rtl="0" algn="ctr">
-              <a:lnSpc>
-                <a:spcPct val="100000"/>
-              </a:lnSpc>
-              <a:spcBef>
-                <a:spcPts val="0"/>
-              </a:spcBef>
-              <a:spcAft>
-                <a:spcPts val="0"/>
-              </a:spcAft>
-              <a:buNone/>
-            </a:pPr>
-            <a:r>
-              <a:rPr b="0" i="0" lang="en" sz="800">
-                <a:solidFill>
-                  <a:srgbClr val="666666"/>
-                </a:solidFill>
-                <a:latin typeface="Arial"/>
-                <a:ea typeface="Arial"/>
-                <a:cs typeface="Arial"/>
-                <a:sym typeface="Arial"/>
-              </a:rPr>
-              <a:t>(higher CTR, lower acquisition cost)</a:t>
-            </a:r>
-            <a:endParaRPr sz="800"/>
-          </a:p>
-        </p:txBody>
-      </p:sp>
-      <p:sp>
-        <p:nvSpPr>
-          <p:cNvPr id="96" name="Google Shape;96;p16"/>
-          <p:cNvSpPr/>
-          <p:nvPr/>
-        </p:nvSpPr>
-        <p:spPr>
-          <a:xfrm>
-            <a:off x="1719072" y="2487168"/>
-            <a:ext cx="5705856" cy="118872"/>
-          </a:xfrm>
-          <a:prstGeom prst="leftArrow">
-            <a:avLst/>
-          </a:prstGeom>
-          <a:solidFill>
-            <a:srgbClr val="A7C142"/>
-          </a:solidFill>
-          <a:ln>
-            <a:noFill/>
+          <a:ln cap="flat" cmpd="sng" w="9525">
+            <a:solidFill>
+              <a:srgbClr val="003726"/>
+            </a:solidFill>
+            <a:prstDash val="solid"/>
+            <a:round/>
+            <a:headEnd len="sm" w="sm" type="none"/>
+            <a:tailEnd len="sm" w="sm" type="none"/>
           </a:ln>
         </p:spPr>
         <p:txBody>
@@ -8510,14 +8911,120 @@
       </p:sp>
       <p:sp>
         <p:nvSpPr>
-          <p:cNvPr id="97" name="Google Shape;97;p16"/>
-          <p:cNvSpPr/>
-          <p:nvPr/>
-        </p:nvSpPr>
-        <p:spPr>
-          <a:xfrm>
-            <a:off x="429768" y="2816352"/>
-            <a:ext cx="8284464" cy="640080"/>
+          <p:cNvPr id="104" name="Google Shape;104;p16"/>
+          <p:cNvSpPr/>
+          <p:nvPr/>
+        </p:nvSpPr>
+        <p:spPr>
+          <a:xfrm>
+            <a:off x="722376" y="3456432"/>
+            <a:ext cx="1298448" cy="420624"/>
+          </a:xfrm>
+          <a:prstGeom prst="rect">
+            <a:avLst/>
+          </a:prstGeom>
+          <a:noFill/>
+          <a:ln>
+            <a:noFill/>
+          </a:ln>
+        </p:spPr>
+        <p:txBody>
+          <a:bodyPr anchorCtr="0" anchor="b" bIns="0" lIns="0" spcFirstLastPara="1" rIns="0" wrap="square" tIns="0">
+            <a:noAutofit/>
+          </a:bodyPr>
+          <a:lstStyle/>
+          <a:p>
+            <a:pPr indent="0" lvl="0" marL="0" marR="0" rtl="0" algn="ctr">
+              <a:lnSpc>
+                <a:spcPct val="100000"/>
+              </a:lnSpc>
+              <a:spcBef>
+                <a:spcPts val="0"/>
+              </a:spcBef>
+              <a:spcAft>
+                <a:spcPts val="0"/>
+              </a:spcAft>
+              <a:buNone/>
+            </a:pPr>
+            <a:r>
+              <a:rPr b="1" i="0" lang="en" sz="800">
+                <a:solidFill>
+                  <a:srgbClr val="003726"/>
+                </a:solidFill>
+                <a:latin typeface="Arial"/>
+                <a:ea typeface="Arial"/>
+                <a:cs typeface="Arial"/>
+                <a:sym typeface="Arial"/>
+              </a:rPr>
+              <a:t>Lower CPL and Higher PPC Conversion Rates</a:t>
+            </a:r>
+            <a:endParaRPr sz="800"/>
+          </a:p>
+        </p:txBody>
+      </p:sp>
+      <p:sp>
+        <p:nvSpPr>
+          <p:cNvPr id="105" name="Google Shape;105;p16"/>
+          <p:cNvSpPr/>
+          <p:nvPr/>
+        </p:nvSpPr>
+        <p:spPr>
+          <a:xfrm>
+            <a:off x="795528" y="3895344"/>
+            <a:ext cx="1152144" cy="347472"/>
+          </a:xfrm>
+          <a:prstGeom prst="rect">
+            <a:avLst/>
+          </a:prstGeom>
+          <a:noFill/>
+          <a:ln>
+            <a:noFill/>
+          </a:ln>
+        </p:spPr>
+        <p:txBody>
+          <a:bodyPr anchorCtr="0" anchor="t" bIns="0" lIns="0" spcFirstLastPara="1" rIns="0" wrap="square" tIns="0">
+            <a:noAutofit/>
+          </a:bodyPr>
+          <a:lstStyle/>
+          <a:p>
+            <a:pPr indent="0" lvl="0" marL="0" marR="0" rtl="0" algn="ctr">
+              <a:lnSpc>
+                <a:spcPct val="100000"/>
+              </a:lnSpc>
+              <a:spcBef>
+                <a:spcPts val="0"/>
+              </a:spcBef>
+              <a:spcAft>
+                <a:spcPts val="0"/>
+              </a:spcAft>
+              <a:buNone/>
+            </a:pPr>
+            <a:r>
+              <a:rPr b="0" i="0" lang="en" sz="700">
+                <a:solidFill>
+                  <a:srgbClr val="666666"/>
+                </a:solidFill>
+                <a:latin typeface="Arial"/>
+                <a:ea typeface="Arial"/>
+                <a:cs typeface="Arial"/>
+                <a:sym typeface="Arial"/>
+              </a:rPr>
+              <a:t>(higher CTR, lower acquisition cost)</a:t>
+            </a:r>
+            <a:endParaRPr sz="700"/>
+          </a:p>
+        </p:txBody>
+      </p:sp>
+      <p:sp>
+        <p:nvSpPr>
+          <p:cNvPr id="106" name="Google Shape;106;p16"/>
+          <p:cNvSpPr/>
+          <p:nvPr/>
+        </p:nvSpPr>
+        <p:spPr>
+          <a:xfrm>
+            <a:off x="4828032" y="1417320"/>
+            <a:ext cx="3886200" cy="914400"/>
           </a:xfrm>
           <a:prstGeom prst="roundRect">
             <a:avLst>
@@ -8564,14 +9071,14 @@
       </p:sp>
       <p:sp>
         <p:nvSpPr>
-          <p:cNvPr id="98" name="Google Shape;98;p16"/>
-          <p:cNvSpPr/>
-          <p:nvPr/>
-        </p:nvSpPr>
-        <p:spPr>
-          <a:xfrm>
-            <a:off x="658368" y="2926080"/>
-            <a:ext cx="7827264" cy="164592"/>
+          <p:cNvPr id="107" name="Google Shape;107;p16"/>
+          <p:cNvSpPr/>
+          <p:nvPr/>
+        </p:nvSpPr>
+        <p:spPr>
+          <a:xfrm>
+            <a:off x="5029200" y="1581912"/>
+            <a:ext cx="3483864" cy="164592"/>
           </a:xfrm>
           <a:prstGeom prst="rect">
             <a:avLst/>
@@ -8614,14 +9121,14 @@
       </p:sp>
       <p:sp>
         <p:nvSpPr>
-          <p:cNvPr id="99" name="Google Shape;99;p16"/>
-          <p:cNvSpPr/>
-          <p:nvPr/>
-        </p:nvSpPr>
-        <p:spPr>
-          <a:xfrm>
-            <a:off x="658368" y="3118104"/>
-            <a:ext cx="7827264" cy="201168"/>
+          <p:cNvPr id="108" name="Google Shape;108;p16"/>
+          <p:cNvSpPr/>
+          <p:nvPr/>
+        </p:nvSpPr>
+        <p:spPr>
+          <a:xfrm>
+            <a:off x="5029200" y="1819656"/>
+            <a:ext cx="3483864" cy="420624"/>
           </a:xfrm>
           <a:prstGeom prst="rect">
             <a:avLst/>
@@ -8632,12 +9139,15 @@
           </a:ln>
         </p:spPr>
         <p:txBody>
-          <a:bodyPr anchorCtr="0" anchor="ctr" bIns="0" lIns="0" spcFirstLastPara="1" rIns="0" wrap="square" tIns="0">
+          <a:bodyPr anchorCtr="0" anchor="t" bIns="0" lIns="0" spcFirstLastPara="1" rIns="0" wrap="square" tIns="0">
             <a:noAutofit/>
           </a:bodyPr>
           <a:lstStyle/>
           <a:p>
             <a:pPr indent="0" lvl="0" marL="0" marR="0" rtl="0" algn="l">
+              <a:lnSpc>
+                <a:spcPct val="115000"/>
+              </a:lnSpc>
               <a:spcBef>
                 <a:spcPts val="0"/>
               </a:spcBef>
@@ -8664,14 +9174,14 @@
       </p:sp>
       <p:sp>
         <p:nvSpPr>
-          <p:cNvPr id="100" name="Google Shape;100;p16"/>
-          <p:cNvSpPr/>
-          <p:nvPr/>
-        </p:nvSpPr>
-        <p:spPr>
-          <a:xfrm>
-            <a:off x="429768" y="3621024"/>
-            <a:ext cx="8284464" cy="914400"/>
+          <p:cNvPr id="109" name="Google Shape;109;p16"/>
+          <p:cNvSpPr/>
+          <p:nvPr/>
+        </p:nvSpPr>
+        <p:spPr>
+          <a:xfrm>
+            <a:off x="4828032" y="2651760"/>
+            <a:ext cx="3886200" cy="1325880"/>
           </a:xfrm>
           <a:prstGeom prst="roundRect">
             <a:avLst>
@@ -8724,14 +9234,14 @@
       </p:sp>
       <p:sp>
         <p:nvSpPr>
-          <p:cNvPr id="101" name="Google Shape;101;p16"/>
-          <p:cNvSpPr/>
-          <p:nvPr/>
-        </p:nvSpPr>
-        <p:spPr>
-          <a:xfrm>
-            <a:off x="658368" y="3749040"/>
-            <a:ext cx="7827264" cy="164592"/>
+          <p:cNvPr id="110" name="Google Shape;110;p16"/>
+          <p:cNvSpPr/>
+          <p:nvPr/>
+        </p:nvSpPr>
+        <p:spPr>
+          <a:xfrm>
+            <a:off x="5029200" y="2816352"/>
+            <a:ext cx="3483864" cy="164592"/>
           </a:xfrm>
           <a:prstGeom prst="rect">
             <a:avLst/>
@@ -8774,14 +9284,14 @@
       </p:sp>
       <p:sp>
         <p:nvSpPr>
-          <p:cNvPr id="102" name="Google Shape;102;p16"/>
-          <p:cNvSpPr/>
-          <p:nvPr/>
-        </p:nvSpPr>
-        <p:spPr>
-          <a:xfrm>
-            <a:off x="658368" y="3986784"/>
-            <a:ext cx="7827264" cy="457200"/>
+          <p:cNvPr id="111" name="Google Shape;111;p16"/>
+          <p:cNvSpPr/>
+          <p:nvPr/>
+        </p:nvSpPr>
+        <p:spPr>
+          <a:xfrm>
+            <a:off x="5029200" y="3072384"/>
+            <a:ext cx="3483864" cy="822960"/>
           </a:xfrm>
           <a:prstGeom prst="rect">
             <a:avLst/>
@@ -8798,11 +9308,14 @@
           <a:lstStyle/>
           <a:p>
             <a:pPr indent="-152400" lvl="0" marL="152400" marR="0" rtl="0" algn="l">
-              <a:spcBef>
-                <a:spcPts val="0"/>
-              </a:spcBef>
-              <a:spcAft>
-                <a:spcPts val="400"/>
+              <a:lnSpc>
+                <a:spcPct val="115000"/>
+              </a:lnSpc>
+              <a:spcBef>
+                <a:spcPts val="0"/>
+              </a:spcBef>
+              <a:spcAft>
+                <a:spcPts val="700"/>
               </a:spcAft>
               <a:buClr>
                 <a:srgbClr val="00823D"/>
@@ -8839,6 +9352,9 @@
           </a:p>
           <a:p>
             <a:pPr indent="-152400" lvl="0" marL="152400" marR="0" rtl="0" algn="l">
+              <a:lnSpc>
+                <a:spcPct val="115000"/>
+              </a:lnSpc>
               <a:spcBef>
                 <a:spcPts val="0"/>
               </a:spcBef>

</xml_diff>